<commit_message>
Update AgentFramework  -  Final.pptx
</commit_message>
<xml_diff>
--- a/AgentFramework  -  Final.pptx
+++ b/AgentFramework  -  Final.pptx
@@ -5,12 +5,13 @@
     <p:sldMasterId id="2147483648" r:id="rId1"/>
   </p:sldMasterIdLst>
   <p:notesMasterIdLst>
-    <p:notesMasterId r:id="rId5"/>
+    <p:notesMasterId r:id="rId6"/>
   </p:notesMasterIdLst>
   <p:sldIdLst>
     <p:sldId id="256" r:id="rId2"/>
     <p:sldId id="257" r:id="rId3"/>
     <p:sldId id="258" r:id="rId4"/>
+    <p:sldId id="259" r:id="rId5"/>
   </p:sldIdLst>
   <p:sldSz cx="9144000" cy="5143500" type="screen16x9"/>
   <p:notesSz cx="5143500" cy="9144000"/>
@@ -139,7 +140,7 @@
     </p:spTree>
     <p:extLst>
       <p:ext uri="{BB962C8B-B14F-4D97-AF65-F5344CB8AC3E}">
-        <p14:creationId xmlns:p14="http://schemas.microsoft.com/office/powerpoint/2010/main" val="191615096"/>
+        <p14:creationId xmlns:p14="http://schemas.microsoft.com/office/powerpoint/2010/main" val="1563181401"/>
       </p:ext>
     </p:extLst>
   </p:cSld>
@@ -473,6 +474,90 @@
             <a:fld id="{F7021451-1387-4CA6-816F-3879F97B5CBC}" type="slidenum">
               <a:rPr lang="en-US"/>
               <a:t>3</a:t>
+            </a:fld>
+            <a:endParaRPr lang="en-US"/>
+          </a:p>
+        </p:txBody>
+      </p:sp>
+    </p:spTree>
+    <p:extLst>
+      <p:ext uri="{BB962C8B-B14F-4D97-AF65-F5344CB8AC3E}">
+        <p14:creationId xmlns:p14="http://schemas.microsoft.com/office/powerpoint/2010/main" val="1024086991"/>
+      </p:ext>
+    </p:extLst>
+  </p:cSld>
+  <p:clrMapOvr>
+    <a:masterClrMapping/>
+  </p:clrMapOvr>
+</p:notes>
+</file>
+
+<file path=ppt/notesSlides/notesSlide4.xml><?xml version="1.0" encoding="utf-8"?>
+<p:notes xmlns:a="http://schemas.openxmlformats.org/drawingml/2006/main" xmlns:r="http://schemas.openxmlformats.org/officeDocument/2006/relationships" xmlns:p="http://schemas.openxmlformats.org/presentationml/2006/main">
+  <p:cSld>
+    <p:spTree>
+      <p:nvGrpSpPr>
+        <p:cNvPr id="1" name=""/>
+        <p:cNvGrpSpPr/>
+        <p:nvPr/>
+      </p:nvGrpSpPr>
+      <p:grpSpPr>
+        <a:xfrm>
+          <a:off x="0" y="0"/>
+          <a:ext cx="0" cy="0"/>
+          <a:chOff x="0" y="0"/>
+          <a:chExt cx="0" cy="0"/>
+        </a:xfrm>
+      </p:grpSpPr>
+      <p:sp>
+        <p:nvSpPr>
+          <p:cNvPr id="2" name="Slide Image Placeholder 1"/>
+          <p:cNvSpPr>
+            <a:spLocks noGrp="1" noRot="1" noChangeAspect="1"/>
+          </p:cNvSpPr>
+          <p:nvPr>
+            <p:ph type="sldImg"/>
+          </p:nvPr>
+        </p:nvSpPr>
+        <p:spPr/>
+      </p:sp>
+      <p:sp>
+        <p:nvSpPr>
+          <p:cNvPr id="3" name="Notes Placeholder 2"/>
+          <p:cNvSpPr>
+            <a:spLocks noGrp="1"/>
+          </p:cNvSpPr>
+          <p:nvPr>
+            <p:ph type="body" idx="1"/>
+          </p:nvPr>
+        </p:nvSpPr>
+        <p:spPr/>
+        <p:txBody>
+          <a:bodyPr/>
+          <a:lstStyle/>
+          <a:p>
+            <a:endParaRPr lang="en-US" dirty="0"/>
+          </a:p>
+        </p:txBody>
+      </p:sp>
+      <p:sp>
+        <p:nvSpPr>
+          <p:cNvPr id="4" name="Slide Number Placeholder 3"/>
+          <p:cNvSpPr>
+            <a:spLocks noGrp="1"/>
+          </p:cNvSpPr>
+          <p:nvPr>
+            <p:ph type="sldNum" sz="quarter" idx="10"/>
+          </p:nvPr>
+        </p:nvSpPr>
+        <p:spPr/>
+        <p:txBody>
+          <a:bodyPr/>
+          <a:lstStyle/>
+          <a:p>
+            <a:fld id="{F7021451-1387-4CA6-816F-3879F97B5CBC}" type="slidenum">
+              <a:rPr lang="en-US"/>
+              <a:t>4</a:t>
             </a:fld>
             <a:endParaRPr lang="en-US"/>
           </a:p>
@@ -6863,49 +6948,6 @@
               </a:rPr>
               <a:t>COVERAGE</a:t>
             </a:r>
-          </a:p>
-          <a:p>
-            <a:pPr marL="0" indent="0">
-              <a:lnSpc>
-                <a:spcPct val="120000"/>
-              </a:lnSpc>
-              <a:buNone/>
-            </a:pPr>
-            <a:r>
-              <a:rPr lang="en-US" sz="650" b="1" i="1" kern="0" spc="200" dirty="0">
-                <a:solidFill>
-                  <a:srgbClr val="00897B"/>
-                </a:solidFill>
-                <a:latin typeface="Calibri" pitchFamily="34" charset="0"/>
-                <a:ea typeface="Calibri" pitchFamily="34" charset="-122"/>
-                <a:cs typeface="Calibri" pitchFamily="34" charset="-120"/>
-              </a:rPr>
-              <a:t>In Progress</a:t>
-            </a:r>
-          </a:p>
-          <a:p>
-            <a:pPr marL="0" indent="0">
-              <a:lnSpc>
-                <a:spcPct val="120000"/>
-              </a:lnSpc>
-              <a:buNone/>
-            </a:pPr>
-            <a:endParaRPr lang="en-US" sz="650" b="1" kern="0" spc="200" dirty="0">
-              <a:solidFill>
-                <a:srgbClr val="00897B"/>
-              </a:solidFill>
-              <a:latin typeface="Calibri" pitchFamily="34" charset="0"/>
-              <a:ea typeface="Calibri" pitchFamily="34" charset="-122"/>
-              <a:cs typeface="Calibri" pitchFamily="34" charset="-120"/>
-            </a:endParaRPr>
-          </a:p>
-          <a:p>
-            <a:pPr marL="0" indent="0">
-              <a:lnSpc>
-                <a:spcPct val="120000"/>
-              </a:lnSpc>
-              <a:buNone/>
-            </a:pPr>
             <a:endParaRPr lang="en-US" sz="650" dirty="0"/>
           </a:p>
         </p:txBody>
@@ -7678,6 +7720,3395 @@
       <p:sp>
         <p:nvSpPr>
           <p:cNvPr id="62" name="Shape 57"/>
+          <p:cNvSpPr/>
+          <p:nvPr/>
+        </p:nvSpPr>
+        <p:spPr>
+          <a:xfrm>
+            <a:off x="0" y="5106924"/>
+            <a:ext cx="9144000" cy="36576"/>
+          </a:xfrm>
+          <a:prstGeom prst="rect">
+            <a:avLst/>
+          </a:prstGeom>
+          <a:solidFill>
+            <a:srgbClr val="D71E28"/>
+          </a:solidFill>
+          <a:ln/>
+        </p:spPr>
+        <p:txBody>
+          <a:bodyPr/>
+          <a:lstStyle/>
+          <a:p>
+            <a:endParaRPr lang="en-US"/>
+          </a:p>
+        </p:txBody>
+      </p:sp>
+    </p:spTree>
+  </p:cSld>
+  <p:clrMapOvr>
+    <a:masterClrMapping/>
+  </p:clrMapOvr>
+</p:sld>
+</file>
+
+<file path=ppt/slides/slide4.xml><?xml version="1.0" encoding="utf-8"?>
+<p:sld xmlns:a="http://schemas.openxmlformats.org/drawingml/2006/main" xmlns:r="http://schemas.openxmlformats.org/officeDocument/2006/relationships" xmlns:p="http://schemas.openxmlformats.org/presentationml/2006/main">
+  <p:cSld name="Slide 4">
+    <p:bg>
+      <p:bgPr>
+        <a:solidFill>
+          <a:srgbClr val="FFFFFF"/>
+        </a:solidFill>
+        <a:effectLst/>
+      </p:bgPr>
+    </p:bg>
+    <p:spTree>
+      <p:nvGrpSpPr>
+        <p:cNvPr id="1" name=""/>
+        <p:cNvGrpSpPr/>
+        <p:nvPr/>
+      </p:nvGrpSpPr>
+      <p:grpSpPr>
+        <a:xfrm>
+          <a:off x="0" y="0"/>
+          <a:ext cx="0" cy="0"/>
+          <a:chOff x="0" y="0"/>
+          <a:chExt cx="0" cy="0"/>
+        </a:xfrm>
+      </p:grpSpPr>
+      <p:sp>
+        <p:nvSpPr>
+          <p:cNvPr id="2" name="Shape 0"/>
+          <p:cNvSpPr/>
+          <p:nvPr/>
+        </p:nvSpPr>
+        <p:spPr>
+          <a:xfrm>
+            <a:off x="0" y="0"/>
+            <a:ext cx="9144000" cy="36576"/>
+          </a:xfrm>
+          <a:prstGeom prst="rect">
+            <a:avLst/>
+          </a:prstGeom>
+          <a:solidFill>
+            <a:srgbClr val="D71E28"/>
+          </a:solidFill>
+          <a:ln/>
+        </p:spPr>
+        <p:txBody>
+          <a:bodyPr/>
+          <a:lstStyle/>
+          <a:p>
+            <a:endParaRPr lang="en-US"/>
+          </a:p>
+        </p:txBody>
+      </p:sp>
+      <p:sp>
+        <p:nvSpPr>
+          <p:cNvPr id="3" name="Text 1"/>
+          <p:cNvSpPr/>
+          <p:nvPr/>
+        </p:nvSpPr>
+        <p:spPr>
+          <a:xfrm>
+            <a:off x="548640" y="128016"/>
+            <a:ext cx="8046720" cy="420624"/>
+          </a:xfrm>
+          <a:prstGeom prst="rect">
+            <a:avLst/>
+          </a:prstGeom>
+          <a:noFill/>
+          <a:ln/>
+        </p:spPr>
+        <p:txBody>
+          <a:bodyPr wrap="square" lIns="0" tIns="0" rIns="0" bIns="0" rtlCol="0" anchor="ctr"/>
+          <a:lstStyle/>
+          <a:p>
+            <a:pPr marL="0" indent="0">
+              <a:buNone/>
+            </a:pPr>
+            <a:r>
+              <a:rPr lang="en-US" sz="2000" b="1" dirty="0">
+                <a:solidFill>
+                  <a:srgbClr val="1A1A2E"/>
+                </a:solidFill>
+                <a:latin typeface="Calibri Light" pitchFamily="34" charset="0"/>
+                <a:ea typeface="Calibri Light" pitchFamily="34" charset="-122"/>
+                <a:cs typeface="Calibri Light" pitchFamily="34" charset="-120"/>
+              </a:rPr>
+              <a:t>How It Works</a:t>
+            </a:r>
+            <a:endParaRPr lang="en-US" sz="2000" dirty="0"/>
+          </a:p>
+        </p:txBody>
+      </p:sp>
+      <p:sp>
+        <p:nvSpPr>
+          <p:cNvPr id="4" name="Shape 2"/>
+          <p:cNvSpPr/>
+          <p:nvPr/>
+        </p:nvSpPr>
+        <p:spPr>
+          <a:xfrm>
+            <a:off x="548640" y="585216"/>
+            <a:ext cx="8046720" cy="0"/>
+          </a:xfrm>
+          <a:prstGeom prst="line">
+            <a:avLst/>
+          </a:prstGeom>
+          <a:noFill/>
+          <a:ln w="9525">
+            <a:solidFill>
+              <a:srgbClr val="E8E8E8"/>
+            </a:solidFill>
+            <a:prstDash val="solid"/>
+          </a:ln>
+        </p:spPr>
+        <p:txBody>
+          <a:bodyPr/>
+          <a:lstStyle/>
+          <a:p>
+            <a:endParaRPr lang="en-US"/>
+          </a:p>
+        </p:txBody>
+      </p:sp>
+      <p:sp>
+        <p:nvSpPr>
+          <p:cNvPr id="5" name="Text 3"/>
+          <p:cNvSpPr/>
+          <p:nvPr/>
+        </p:nvSpPr>
+        <p:spPr>
+          <a:xfrm>
+            <a:off x="548640" y="841248"/>
+            <a:ext cx="3657600" cy="164592"/>
+          </a:xfrm>
+          <a:prstGeom prst="rect">
+            <a:avLst/>
+          </a:prstGeom>
+          <a:noFill/>
+          <a:ln/>
+        </p:spPr>
+        <p:txBody>
+          <a:bodyPr wrap="square" lIns="0" tIns="0" rIns="0" bIns="0" rtlCol="0" anchor="ctr"/>
+          <a:lstStyle/>
+          <a:p>
+            <a:pPr marL="0" indent="0">
+              <a:buNone/>
+            </a:pPr>
+            <a:r>
+              <a:rPr lang="en-US" sz="700" b="1" kern="0" spc="200" dirty="0">
+                <a:solidFill>
+                  <a:srgbClr val="00897B"/>
+                </a:solidFill>
+                <a:latin typeface="Calibri" pitchFamily="34" charset="0"/>
+                <a:ea typeface="Calibri" pitchFamily="34" charset="-122"/>
+                <a:cs typeface="Calibri" pitchFamily="34" charset="-120"/>
+              </a:rPr>
+              <a:t>SERVICE  PROVIDER  ONBOARDING</a:t>
+            </a:r>
+            <a:endParaRPr lang="en-US" sz="700" dirty="0"/>
+          </a:p>
+        </p:txBody>
+      </p:sp>
+      <p:sp>
+        <p:nvSpPr>
+          <p:cNvPr id="6" name="Shape 4"/>
+          <p:cNvSpPr/>
+          <p:nvPr/>
+        </p:nvSpPr>
+        <p:spPr>
+          <a:xfrm>
+            <a:off x="640080" y="1371600"/>
+            <a:ext cx="1243584" cy="512064"/>
+          </a:xfrm>
+          <a:prstGeom prst="rect">
+            <a:avLst/>
+          </a:prstGeom>
+          <a:solidFill>
+            <a:srgbClr val="F5F5F5"/>
+          </a:solidFill>
+          <a:ln w="6350">
+            <a:solidFill>
+              <a:srgbClr val="E8E8E8"/>
+            </a:solidFill>
+            <a:prstDash val="solid"/>
+          </a:ln>
+          <a:effectLst>
+            <a:outerShdw blurRad="38100" dist="12700" dir="8100000" algn="bl" rotWithShape="0">
+              <a:srgbClr val="000000">
+                <a:alpha val="6000"/>
+              </a:srgbClr>
+            </a:outerShdw>
+          </a:effectLst>
+        </p:spPr>
+        <p:txBody>
+          <a:bodyPr/>
+          <a:lstStyle/>
+          <a:p>
+            <a:endParaRPr lang="en-US"/>
+          </a:p>
+        </p:txBody>
+      </p:sp>
+      <p:sp>
+        <p:nvSpPr>
+          <p:cNvPr id="7" name="Shape 5"/>
+          <p:cNvSpPr/>
+          <p:nvPr/>
+        </p:nvSpPr>
+        <p:spPr>
+          <a:xfrm>
+            <a:off x="640080" y="1371600"/>
+            <a:ext cx="1243584" cy="27432"/>
+          </a:xfrm>
+          <a:prstGeom prst="rect">
+            <a:avLst/>
+          </a:prstGeom>
+          <a:solidFill>
+            <a:srgbClr val="00897B"/>
+          </a:solidFill>
+          <a:ln/>
+        </p:spPr>
+        <p:txBody>
+          <a:bodyPr/>
+          <a:lstStyle/>
+          <a:p>
+            <a:endParaRPr lang="en-US"/>
+          </a:p>
+        </p:txBody>
+      </p:sp>
+      <p:sp>
+        <p:nvSpPr>
+          <p:cNvPr id="8" name="Text 6"/>
+          <p:cNvSpPr/>
+          <p:nvPr/>
+        </p:nvSpPr>
+        <p:spPr>
+          <a:xfrm>
+            <a:off x="694944" y="1426464"/>
+            <a:ext cx="1133856" cy="201168"/>
+          </a:xfrm>
+          <a:prstGeom prst="rect">
+            <a:avLst/>
+          </a:prstGeom>
+          <a:noFill/>
+          <a:ln/>
+        </p:spPr>
+        <p:txBody>
+          <a:bodyPr wrap="square" lIns="0" tIns="0" rIns="0" bIns="0" rtlCol="0" anchor="ctr"/>
+          <a:lstStyle/>
+          <a:p>
+            <a:pPr marL="0" indent="0">
+              <a:buNone/>
+            </a:pPr>
+            <a:r>
+              <a:rPr lang="en-US" sz="900" b="1" dirty="0">
+                <a:solidFill>
+                  <a:srgbClr val="263238"/>
+                </a:solidFill>
+                <a:latin typeface="Calibri" pitchFamily="34" charset="0"/>
+                <a:ea typeface="Calibri" pitchFamily="34" charset="-122"/>
+                <a:cs typeface="Calibri" pitchFamily="34" charset="-120"/>
+              </a:rPr>
+              <a:t>Submit</a:t>
+            </a:r>
+            <a:endParaRPr lang="en-US" sz="900" dirty="0"/>
+          </a:p>
+        </p:txBody>
+      </p:sp>
+      <p:sp>
+        <p:nvSpPr>
+          <p:cNvPr id="9" name="Text 7"/>
+          <p:cNvSpPr/>
+          <p:nvPr/>
+        </p:nvSpPr>
+        <p:spPr>
+          <a:xfrm>
+            <a:off x="694944" y="1627632"/>
+            <a:ext cx="1133856" cy="201168"/>
+          </a:xfrm>
+          <a:prstGeom prst="rect">
+            <a:avLst/>
+          </a:prstGeom>
+          <a:noFill/>
+          <a:ln/>
+        </p:spPr>
+        <p:txBody>
+          <a:bodyPr wrap="square" lIns="0" tIns="0" rIns="0" bIns="0" rtlCol="0" anchor="t"/>
+          <a:lstStyle/>
+          <a:p>
+            <a:pPr marL="0" indent="0">
+              <a:buNone/>
+            </a:pPr>
+            <a:r>
+              <a:rPr lang="en-US" sz="650" dirty="0">
+                <a:solidFill>
+                  <a:srgbClr val="78909C"/>
+                </a:solidFill>
+                <a:latin typeface="Calibri" pitchFamily="34" charset="0"/>
+                <a:ea typeface="Calibri" pitchFamily="34" charset="-122"/>
+                <a:cs typeface="Calibri" pitchFamily="34" charset="-120"/>
+              </a:rPr>
+              <a:t>Service team submits</a:t>
+            </a:r>
+            <a:endParaRPr lang="en-US" sz="650" dirty="0"/>
+          </a:p>
+          <a:p>
+            <a:pPr marL="0" indent="0">
+              <a:buNone/>
+            </a:pPr>
+            <a:r>
+              <a:rPr lang="en-US" sz="650" dirty="0">
+                <a:solidFill>
+                  <a:srgbClr val="78909C"/>
+                </a:solidFill>
+                <a:latin typeface="Calibri" pitchFamily="34" charset="0"/>
+                <a:ea typeface="Calibri" pitchFamily="34" charset="-122"/>
+                <a:cs typeface="Calibri" pitchFamily="34" charset="-120"/>
+              </a:rPr>
+              <a:t>agent proposal &amp; use case</a:t>
+            </a:r>
+            <a:endParaRPr lang="en-US" sz="650" dirty="0"/>
+          </a:p>
+        </p:txBody>
+      </p:sp>
+      <p:sp>
+        <p:nvSpPr>
+          <p:cNvPr id="10" name="Shape 8"/>
+          <p:cNvSpPr/>
+          <p:nvPr/>
+        </p:nvSpPr>
+        <p:spPr>
+          <a:xfrm>
+            <a:off x="2176272" y="1371600"/>
+            <a:ext cx="1243584" cy="512064"/>
+          </a:xfrm>
+          <a:prstGeom prst="rect">
+            <a:avLst/>
+          </a:prstGeom>
+          <a:solidFill>
+            <a:srgbClr val="F5F5F5"/>
+          </a:solidFill>
+          <a:ln w="6350">
+            <a:solidFill>
+              <a:srgbClr val="E8E8E8"/>
+            </a:solidFill>
+            <a:prstDash val="solid"/>
+          </a:ln>
+          <a:effectLst>
+            <a:outerShdw blurRad="38100" dist="12700" dir="8100000" algn="bl" rotWithShape="0">
+              <a:srgbClr val="000000">
+                <a:alpha val="6000"/>
+              </a:srgbClr>
+            </a:outerShdw>
+          </a:effectLst>
+        </p:spPr>
+        <p:txBody>
+          <a:bodyPr/>
+          <a:lstStyle/>
+          <a:p>
+            <a:endParaRPr lang="en-US"/>
+          </a:p>
+        </p:txBody>
+      </p:sp>
+      <p:sp>
+        <p:nvSpPr>
+          <p:cNvPr id="11" name="Shape 9"/>
+          <p:cNvSpPr/>
+          <p:nvPr/>
+        </p:nvSpPr>
+        <p:spPr>
+          <a:xfrm>
+            <a:off x="2176272" y="1371600"/>
+            <a:ext cx="1243584" cy="27432"/>
+          </a:xfrm>
+          <a:prstGeom prst="rect">
+            <a:avLst/>
+          </a:prstGeom>
+          <a:solidFill>
+            <a:srgbClr val="00897B"/>
+          </a:solidFill>
+          <a:ln/>
+        </p:spPr>
+        <p:txBody>
+          <a:bodyPr/>
+          <a:lstStyle/>
+          <a:p>
+            <a:endParaRPr lang="en-US"/>
+          </a:p>
+        </p:txBody>
+      </p:sp>
+      <p:sp>
+        <p:nvSpPr>
+          <p:cNvPr id="12" name="Text 10"/>
+          <p:cNvSpPr/>
+          <p:nvPr/>
+        </p:nvSpPr>
+        <p:spPr>
+          <a:xfrm>
+            <a:off x="2231136" y="1426464"/>
+            <a:ext cx="1133856" cy="201168"/>
+          </a:xfrm>
+          <a:prstGeom prst="rect">
+            <a:avLst/>
+          </a:prstGeom>
+          <a:noFill/>
+          <a:ln/>
+        </p:spPr>
+        <p:txBody>
+          <a:bodyPr wrap="square" lIns="0" tIns="0" rIns="0" bIns="0" rtlCol="0" anchor="ctr"/>
+          <a:lstStyle/>
+          <a:p>
+            <a:pPr marL="0" indent="0">
+              <a:buNone/>
+            </a:pPr>
+            <a:r>
+              <a:rPr lang="en-US" sz="900" b="1" dirty="0">
+                <a:solidFill>
+                  <a:srgbClr val="263238"/>
+                </a:solidFill>
+                <a:latin typeface="Calibri" pitchFamily="34" charset="0"/>
+                <a:ea typeface="Calibri" pitchFamily="34" charset="-122"/>
+                <a:cs typeface="Calibri" pitchFamily="34" charset="-120"/>
+              </a:rPr>
+              <a:t>Review</a:t>
+            </a:r>
+            <a:endParaRPr lang="en-US" sz="900" dirty="0"/>
+          </a:p>
+        </p:txBody>
+      </p:sp>
+      <p:sp>
+        <p:nvSpPr>
+          <p:cNvPr id="13" name="Text 11"/>
+          <p:cNvSpPr/>
+          <p:nvPr/>
+        </p:nvSpPr>
+        <p:spPr>
+          <a:xfrm>
+            <a:off x="2231136" y="1627632"/>
+            <a:ext cx="1133856" cy="201168"/>
+          </a:xfrm>
+          <a:prstGeom prst="rect">
+            <a:avLst/>
+          </a:prstGeom>
+          <a:noFill/>
+          <a:ln/>
+        </p:spPr>
+        <p:txBody>
+          <a:bodyPr wrap="square" lIns="0" tIns="0" rIns="0" bIns="0" rtlCol="0" anchor="t"/>
+          <a:lstStyle/>
+          <a:p>
+            <a:pPr marL="0" indent="0">
+              <a:buNone/>
+            </a:pPr>
+            <a:r>
+              <a:rPr lang="en-US" sz="650" dirty="0">
+                <a:solidFill>
+                  <a:srgbClr val="78909C"/>
+                </a:solidFill>
+                <a:latin typeface="Calibri" pitchFamily="34" charset="0"/>
+                <a:ea typeface="Calibri" pitchFamily="34" charset="-122"/>
+                <a:cs typeface="Calibri" pitchFamily="34" charset="-120"/>
+              </a:rPr>
+              <a:t>Dual-gate review:</a:t>
+            </a:r>
+            <a:endParaRPr lang="en-US" sz="650" dirty="0"/>
+          </a:p>
+          <a:p>
+            <a:pPr marL="0" indent="0">
+              <a:buNone/>
+            </a:pPr>
+            <a:r>
+              <a:rPr lang="en-US" sz="650" dirty="0">
+                <a:solidFill>
+                  <a:srgbClr val="78909C"/>
+                </a:solidFill>
+                <a:latin typeface="Calibri" pitchFamily="34" charset="0"/>
+                <a:ea typeface="Calibri" pitchFamily="34" charset="-122"/>
+                <a:cs typeface="Calibri" pitchFamily="34" charset="-120"/>
+              </a:rPr>
+              <a:t>content &amp; functional</a:t>
+            </a:r>
+            <a:endParaRPr lang="en-US" sz="650" dirty="0"/>
+          </a:p>
+        </p:txBody>
+      </p:sp>
+      <p:sp>
+        <p:nvSpPr>
+          <p:cNvPr id="14" name="Shape 12"/>
+          <p:cNvSpPr/>
+          <p:nvPr/>
+        </p:nvSpPr>
+        <p:spPr>
+          <a:xfrm>
+            <a:off x="3712464" y="1371600"/>
+            <a:ext cx="1243584" cy="512064"/>
+          </a:xfrm>
+          <a:prstGeom prst="rect">
+            <a:avLst/>
+          </a:prstGeom>
+          <a:solidFill>
+            <a:srgbClr val="F5F5F5"/>
+          </a:solidFill>
+          <a:ln w="6350">
+            <a:solidFill>
+              <a:srgbClr val="E8E8E8"/>
+            </a:solidFill>
+            <a:prstDash val="solid"/>
+          </a:ln>
+          <a:effectLst>
+            <a:outerShdw blurRad="38100" dist="12700" dir="8100000" algn="bl" rotWithShape="0">
+              <a:srgbClr val="000000">
+                <a:alpha val="6000"/>
+              </a:srgbClr>
+            </a:outerShdw>
+          </a:effectLst>
+        </p:spPr>
+        <p:txBody>
+          <a:bodyPr/>
+          <a:lstStyle/>
+          <a:p>
+            <a:endParaRPr lang="en-US"/>
+          </a:p>
+        </p:txBody>
+      </p:sp>
+      <p:sp>
+        <p:nvSpPr>
+          <p:cNvPr id="15" name="Shape 13"/>
+          <p:cNvSpPr/>
+          <p:nvPr/>
+        </p:nvSpPr>
+        <p:spPr>
+          <a:xfrm>
+            <a:off x="3712464" y="1371600"/>
+            <a:ext cx="1243584" cy="27432"/>
+          </a:xfrm>
+          <a:prstGeom prst="rect">
+            <a:avLst/>
+          </a:prstGeom>
+          <a:solidFill>
+            <a:srgbClr val="00897B"/>
+          </a:solidFill>
+          <a:ln/>
+        </p:spPr>
+        <p:txBody>
+          <a:bodyPr/>
+          <a:lstStyle/>
+          <a:p>
+            <a:endParaRPr lang="en-US"/>
+          </a:p>
+        </p:txBody>
+      </p:sp>
+      <p:sp>
+        <p:nvSpPr>
+          <p:cNvPr id="16" name="Text 14"/>
+          <p:cNvSpPr/>
+          <p:nvPr/>
+        </p:nvSpPr>
+        <p:spPr>
+          <a:xfrm>
+            <a:off x="3767328" y="1426464"/>
+            <a:ext cx="1133856" cy="201168"/>
+          </a:xfrm>
+          <a:prstGeom prst="rect">
+            <a:avLst/>
+          </a:prstGeom>
+          <a:noFill/>
+          <a:ln/>
+        </p:spPr>
+        <p:txBody>
+          <a:bodyPr wrap="square" lIns="0" tIns="0" rIns="0" bIns="0" rtlCol="0" anchor="ctr"/>
+          <a:lstStyle/>
+          <a:p>
+            <a:pPr marL="0" indent="0">
+              <a:buNone/>
+            </a:pPr>
+            <a:r>
+              <a:rPr lang="en-US" sz="900" b="1" dirty="0">
+                <a:solidFill>
+                  <a:srgbClr val="263238"/>
+                </a:solidFill>
+                <a:latin typeface="Calibri" pitchFamily="34" charset="0"/>
+                <a:ea typeface="Calibri" pitchFamily="34" charset="-122"/>
+                <a:cs typeface="Calibri" pitchFamily="34" charset="-120"/>
+              </a:rPr>
+              <a:t>Approve</a:t>
+            </a:r>
+            <a:endParaRPr lang="en-US" sz="900" dirty="0"/>
+          </a:p>
+        </p:txBody>
+      </p:sp>
+      <p:sp>
+        <p:nvSpPr>
+          <p:cNvPr id="17" name="Text 15"/>
+          <p:cNvSpPr/>
+          <p:nvPr/>
+        </p:nvSpPr>
+        <p:spPr>
+          <a:xfrm>
+            <a:off x="3767328" y="1627632"/>
+            <a:ext cx="1133856" cy="201168"/>
+          </a:xfrm>
+          <a:prstGeom prst="rect">
+            <a:avLst/>
+          </a:prstGeom>
+          <a:noFill/>
+          <a:ln/>
+        </p:spPr>
+        <p:txBody>
+          <a:bodyPr wrap="square" lIns="0" tIns="0" rIns="0" bIns="0" rtlCol="0" anchor="t"/>
+          <a:lstStyle/>
+          <a:p>
+            <a:pPr marL="0" indent="0">
+              <a:buNone/>
+            </a:pPr>
+            <a:r>
+              <a:rPr lang="en-US" sz="650" dirty="0">
+                <a:solidFill>
+                  <a:srgbClr val="78909C"/>
+                </a:solidFill>
+                <a:latin typeface="Calibri" pitchFamily="34" charset="0"/>
+                <a:ea typeface="Calibri" pitchFamily="34" charset="-122"/>
+                <a:cs typeface="Calibri" pitchFamily="34" charset="-120"/>
+              </a:rPr>
+              <a:t>Agent approved for</a:t>
+            </a:r>
+            <a:endParaRPr lang="en-US" sz="650" dirty="0"/>
+          </a:p>
+          <a:p>
+            <a:pPr marL="0" indent="0">
+              <a:buNone/>
+            </a:pPr>
+            <a:r>
+              <a:rPr lang="en-US" sz="650" dirty="0">
+                <a:solidFill>
+                  <a:srgbClr val="78909C"/>
+                </a:solidFill>
+                <a:latin typeface="Calibri" pitchFamily="34" charset="0"/>
+                <a:ea typeface="Calibri" pitchFamily="34" charset="-122"/>
+                <a:cs typeface="Calibri" pitchFamily="34" charset="-120"/>
+              </a:rPr>
+              <a:t>integration into framework</a:t>
+            </a:r>
+            <a:endParaRPr lang="en-US" sz="650" dirty="0"/>
+          </a:p>
+        </p:txBody>
+      </p:sp>
+      <p:sp>
+        <p:nvSpPr>
+          <p:cNvPr id="18" name="Shape 16"/>
+          <p:cNvSpPr/>
+          <p:nvPr/>
+        </p:nvSpPr>
+        <p:spPr>
+          <a:xfrm>
+            <a:off x="5248656" y="1371600"/>
+            <a:ext cx="1243584" cy="512064"/>
+          </a:xfrm>
+          <a:prstGeom prst="rect">
+            <a:avLst/>
+          </a:prstGeom>
+          <a:solidFill>
+            <a:srgbClr val="F5F5F5"/>
+          </a:solidFill>
+          <a:ln w="6350">
+            <a:solidFill>
+              <a:srgbClr val="E8E8E8"/>
+            </a:solidFill>
+            <a:prstDash val="solid"/>
+          </a:ln>
+          <a:effectLst>
+            <a:outerShdw blurRad="38100" dist="12700" dir="8100000" algn="bl" rotWithShape="0">
+              <a:srgbClr val="000000">
+                <a:alpha val="6000"/>
+              </a:srgbClr>
+            </a:outerShdw>
+          </a:effectLst>
+        </p:spPr>
+        <p:txBody>
+          <a:bodyPr/>
+          <a:lstStyle/>
+          <a:p>
+            <a:endParaRPr lang="en-US"/>
+          </a:p>
+        </p:txBody>
+      </p:sp>
+      <p:sp>
+        <p:nvSpPr>
+          <p:cNvPr id="19" name="Shape 17"/>
+          <p:cNvSpPr/>
+          <p:nvPr/>
+        </p:nvSpPr>
+        <p:spPr>
+          <a:xfrm>
+            <a:off x="5248656" y="1371600"/>
+            <a:ext cx="1243584" cy="27432"/>
+          </a:xfrm>
+          <a:prstGeom prst="rect">
+            <a:avLst/>
+          </a:prstGeom>
+          <a:solidFill>
+            <a:srgbClr val="00897B"/>
+          </a:solidFill>
+          <a:ln/>
+        </p:spPr>
+        <p:txBody>
+          <a:bodyPr/>
+          <a:lstStyle/>
+          <a:p>
+            <a:endParaRPr lang="en-US"/>
+          </a:p>
+        </p:txBody>
+      </p:sp>
+      <p:sp>
+        <p:nvSpPr>
+          <p:cNvPr id="20" name="Text 18"/>
+          <p:cNvSpPr/>
+          <p:nvPr/>
+        </p:nvSpPr>
+        <p:spPr>
+          <a:xfrm>
+            <a:off x="5303520" y="1426464"/>
+            <a:ext cx="1133856" cy="201168"/>
+          </a:xfrm>
+          <a:prstGeom prst="rect">
+            <a:avLst/>
+          </a:prstGeom>
+          <a:noFill/>
+          <a:ln/>
+        </p:spPr>
+        <p:txBody>
+          <a:bodyPr wrap="square" lIns="0" tIns="0" rIns="0" bIns="0" rtlCol="0" anchor="ctr"/>
+          <a:lstStyle/>
+          <a:p>
+            <a:pPr marL="0" indent="0">
+              <a:buNone/>
+            </a:pPr>
+            <a:r>
+              <a:rPr lang="en-US" sz="900" b="1" dirty="0">
+                <a:solidFill>
+                  <a:srgbClr val="263238"/>
+                </a:solidFill>
+                <a:latin typeface="Calibri" pitchFamily="34" charset="0"/>
+                <a:ea typeface="Calibri" pitchFamily="34" charset="-122"/>
+                <a:cs typeface="Calibri" pitchFamily="34" charset="-120"/>
+              </a:rPr>
+              <a:t>Integrate</a:t>
+            </a:r>
+            <a:endParaRPr lang="en-US" sz="900" dirty="0"/>
+          </a:p>
+        </p:txBody>
+      </p:sp>
+      <p:sp>
+        <p:nvSpPr>
+          <p:cNvPr id="21" name="Text 19"/>
+          <p:cNvSpPr/>
+          <p:nvPr/>
+        </p:nvSpPr>
+        <p:spPr>
+          <a:xfrm>
+            <a:off x="5303520" y="1627632"/>
+            <a:ext cx="1133856" cy="201168"/>
+          </a:xfrm>
+          <a:prstGeom prst="rect">
+            <a:avLst/>
+          </a:prstGeom>
+          <a:noFill/>
+          <a:ln/>
+        </p:spPr>
+        <p:txBody>
+          <a:bodyPr wrap="square" lIns="0" tIns="0" rIns="0" bIns="0" rtlCol="0" anchor="t"/>
+          <a:lstStyle/>
+          <a:p>
+            <a:pPr marL="0" indent="0">
+              <a:buNone/>
+            </a:pPr>
+            <a:r>
+              <a:rPr lang="en-US" sz="650" dirty="0">
+                <a:solidFill>
+                  <a:srgbClr val="78909C"/>
+                </a:solidFill>
+                <a:latin typeface="Calibri" pitchFamily="34" charset="0"/>
+                <a:ea typeface="Calibri" pitchFamily="34" charset="-122"/>
+                <a:cs typeface="Calibri" pitchFamily="34" charset="-120"/>
+              </a:rPr>
+              <a:t>MCP &amp; documentation</a:t>
+            </a:r>
+            <a:endParaRPr lang="en-US" sz="650" dirty="0"/>
+          </a:p>
+          <a:p>
+            <a:pPr marL="0" indent="0">
+              <a:buNone/>
+            </a:pPr>
+            <a:r>
+              <a:rPr lang="en-US" sz="650" dirty="0">
+                <a:solidFill>
+                  <a:srgbClr val="78909C"/>
+                </a:solidFill>
+                <a:latin typeface="Calibri" pitchFamily="34" charset="0"/>
+                <a:ea typeface="Calibri" pitchFamily="34" charset="-122"/>
+                <a:cs typeface="Calibri" pitchFamily="34" charset="-120"/>
+              </a:rPr>
+              <a:t>onboarding paths</a:t>
+            </a:r>
+            <a:endParaRPr lang="en-US" sz="650" dirty="0"/>
+          </a:p>
+        </p:txBody>
+      </p:sp>
+      <p:sp>
+        <p:nvSpPr>
+          <p:cNvPr id="22" name="Shape 20"/>
+          <p:cNvSpPr/>
+          <p:nvPr/>
+        </p:nvSpPr>
+        <p:spPr>
+          <a:xfrm>
+            <a:off x="6784848" y="1371600"/>
+            <a:ext cx="1243584" cy="512064"/>
+          </a:xfrm>
+          <a:prstGeom prst="rect">
+            <a:avLst/>
+          </a:prstGeom>
+          <a:solidFill>
+            <a:srgbClr val="F5F5F5"/>
+          </a:solidFill>
+          <a:ln w="6350">
+            <a:solidFill>
+              <a:srgbClr val="E8E8E8"/>
+            </a:solidFill>
+            <a:prstDash val="solid"/>
+          </a:ln>
+          <a:effectLst>
+            <a:outerShdw blurRad="38100" dist="12700" dir="8100000" algn="bl" rotWithShape="0">
+              <a:srgbClr val="000000">
+                <a:alpha val="6000"/>
+              </a:srgbClr>
+            </a:outerShdw>
+          </a:effectLst>
+        </p:spPr>
+        <p:txBody>
+          <a:bodyPr/>
+          <a:lstStyle/>
+          <a:p>
+            <a:endParaRPr lang="en-US"/>
+          </a:p>
+        </p:txBody>
+      </p:sp>
+      <p:sp>
+        <p:nvSpPr>
+          <p:cNvPr id="23" name="Shape 21"/>
+          <p:cNvSpPr/>
+          <p:nvPr/>
+        </p:nvSpPr>
+        <p:spPr>
+          <a:xfrm>
+            <a:off x="6784848" y="1371600"/>
+            <a:ext cx="1243584" cy="27432"/>
+          </a:xfrm>
+          <a:prstGeom prst="rect">
+            <a:avLst/>
+          </a:prstGeom>
+          <a:solidFill>
+            <a:srgbClr val="00897B"/>
+          </a:solidFill>
+          <a:ln/>
+        </p:spPr>
+        <p:txBody>
+          <a:bodyPr/>
+          <a:lstStyle/>
+          <a:p>
+            <a:endParaRPr lang="en-US"/>
+          </a:p>
+        </p:txBody>
+      </p:sp>
+      <p:sp>
+        <p:nvSpPr>
+          <p:cNvPr id="24" name="Text 22"/>
+          <p:cNvSpPr/>
+          <p:nvPr/>
+        </p:nvSpPr>
+        <p:spPr>
+          <a:xfrm>
+            <a:off x="6839712" y="1426464"/>
+            <a:ext cx="1133856" cy="201168"/>
+          </a:xfrm>
+          <a:prstGeom prst="rect">
+            <a:avLst/>
+          </a:prstGeom>
+          <a:noFill/>
+          <a:ln/>
+        </p:spPr>
+        <p:txBody>
+          <a:bodyPr wrap="square" lIns="0" tIns="0" rIns="0" bIns="0" rtlCol="0" anchor="ctr"/>
+          <a:lstStyle/>
+          <a:p>
+            <a:pPr marL="0" indent="0">
+              <a:buNone/>
+            </a:pPr>
+            <a:r>
+              <a:rPr lang="en-US" sz="900" b="1" dirty="0">
+                <a:solidFill>
+                  <a:srgbClr val="263238"/>
+                </a:solidFill>
+                <a:latin typeface="Calibri" pitchFamily="34" charset="0"/>
+                <a:ea typeface="Calibri" pitchFamily="34" charset="-122"/>
+                <a:cs typeface="Calibri" pitchFamily="34" charset="-120"/>
+              </a:rPr>
+              <a:t>Evaluate</a:t>
+            </a:r>
+            <a:endParaRPr lang="en-US" sz="900" dirty="0"/>
+          </a:p>
+        </p:txBody>
+      </p:sp>
+      <p:sp>
+        <p:nvSpPr>
+          <p:cNvPr id="25" name="Text 23"/>
+          <p:cNvSpPr/>
+          <p:nvPr/>
+        </p:nvSpPr>
+        <p:spPr>
+          <a:xfrm>
+            <a:off x="6839712" y="1627632"/>
+            <a:ext cx="1133856" cy="201168"/>
+          </a:xfrm>
+          <a:prstGeom prst="rect">
+            <a:avLst/>
+          </a:prstGeom>
+          <a:noFill/>
+          <a:ln/>
+        </p:spPr>
+        <p:txBody>
+          <a:bodyPr wrap="square" lIns="0" tIns="0" rIns="0" bIns="0" rtlCol="0" anchor="t"/>
+          <a:lstStyle/>
+          <a:p>
+            <a:pPr marL="0" indent="0">
+              <a:buNone/>
+            </a:pPr>
+            <a:r>
+              <a:rPr lang="en-US" sz="650" dirty="0">
+                <a:solidFill>
+                  <a:srgbClr val="78909C"/>
+                </a:solidFill>
+                <a:latin typeface="Calibri" pitchFamily="34" charset="0"/>
+                <a:ea typeface="Calibri" pitchFamily="34" charset="-122"/>
+                <a:cs typeface="Calibri" pitchFamily="34" charset="-120"/>
+              </a:rPr>
+              <a:t>Quality, hallucination &amp;</a:t>
+            </a:r>
+            <a:endParaRPr lang="en-US" sz="650" dirty="0"/>
+          </a:p>
+          <a:p>
+            <a:pPr marL="0" indent="0">
+              <a:buNone/>
+            </a:pPr>
+            <a:r>
+              <a:rPr lang="en-US" sz="650" dirty="0">
+                <a:solidFill>
+                  <a:srgbClr val="78909C"/>
+                </a:solidFill>
+                <a:latin typeface="Calibri" pitchFamily="34" charset="0"/>
+                <a:ea typeface="Calibri" pitchFamily="34" charset="-122"/>
+                <a:cs typeface="Calibri" pitchFamily="34" charset="-120"/>
+              </a:rPr>
+              <a:t>performance validation</a:t>
+            </a:r>
+            <a:endParaRPr lang="en-US" sz="650" dirty="0"/>
+          </a:p>
+        </p:txBody>
+      </p:sp>
+      <p:sp>
+        <p:nvSpPr>
+          <p:cNvPr id="26" name="Shape 24"/>
+          <p:cNvSpPr/>
+          <p:nvPr/>
+        </p:nvSpPr>
+        <p:spPr>
+          <a:xfrm>
+            <a:off x="1920240" y="1627632"/>
+            <a:ext cx="219456" cy="0"/>
+          </a:xfrm>
+          <a:prstGeom prst="line">
+            <a:avLst/>
+          </a:prstGeom>
+          <a:noFill/>
+          <a:ln w="12700">
+            <a:solidFill>
+              <a:srgbClr val="00897B"/>
+            </a:solidFill>
+            <a:prstDash val="solid"/>
+            <a:tailEnd type="triangle"/>
+          </a:ln>
+        </p:spPr>
+        <p:txBody>
+          <a:bodyPr/>
+          <a:lstStyle/>
+          <a:p>
+            <a:endParaRPr lang="en-US"/>
+          </a:p>
+        </p:txBody>
+      </p:sp>
+      <p:sp>
+        <p:nvSpPr>
+          <p:cNvPr id="27" name="Shape 25"/>
+          <p:cNvSpPr/>
+          <p:nvPr/>
+        </p:nvSpPr>
+        <p:spPr>
+          <a:xfrm>
+            <a:off x="3456432" y="1627632"/>
+            <a:ext cx="219456" cy="0"/>
+          </a:xfrm>
+          <a:prstGeom prst="line">
+            <a:avLst/>
+          </a:prstGeom>
+          <a:noFill/>
+          <a:ln w="12700">
+            <a:solidFill>
+              <a:srgbClr val="00897B"/>
+            </a:solidFill>
+            <a:prstDash val="solid"/>
+            <a:tailEnd type="triangle"/>
+          </a:ln>
+        </p:spPr>
+        <p:txBody>
+          <a:bodyPr/>
+          <a:lstStyle/>
+          <a:p>
+            <a:endParaRPr lang="en-US"/>
+          </a:p>
+        </p:txBody>
+      </p:sp>
+      <p:sp>
+        <p:nvSpPr>
+          <p:cNvPr id="28" name="Shape 26"/>
+          <p:cNvSpPr/>
+          <p:nvPr/>
+        </p:nvSpPr>
+        <p:spPr>
+          <a:xfrm>
+            <a:off x="4992624" y="1627632"/>
+            <a:ext cx="219456" cy="0"/>
+          </a:xfrm>
+          <a:prstGeom prst="line">
+            <a:avLst/>
+          </a:prstGeom>
+          <a:noFill/>
+          <a:ln w="12700">
+            <a:solidFill>
+              <a:srgbClr val="00897B"/>
+            </a:solidFill>
+            <a:prstDash val="solid"/>
+            <a:tailEnd type="triangle"/>
+          </a:ln>
+        </p:spPr>
+        <p:txBody>
+          <a:bodyPr/>
+          <a:lstStyle/>
+          <a:p>
+            <a:endParaRPr lang="en-US"/>
+          </a:p>
+        </p:txBody>
+      </p:sp>
+      <p:sp>
+        <p:nvSpPr>
+          <p:cNvPr id="29" name="Shape 27"/>
+          <p:cNvSpPr/>
+          <p:nvPr/>
+        </p:nvSpPr>
+        <p:spPr>
+          <a:xfrm>
+            <a:off x="6528816" y="1627632"/>
+            <a:ext cx="219456" cy="0"/>
+          </a:xfrm>
+          <a:prstGeom prst="line">
+            <a:avLst/>
+          </a:prstGeom>
+          <a:noFill/>
+          <a:ln w="12700">
+            <a:solidFill>
+              <a:srgbClr val="00897B"/>
+            </a:solidFill>
+            <a:prstDash val="solid"/>
+            <a:tailEnd type="triangle"/>
+          </a:ln>
+        </p:spPr>
+        <p:txBody>
+          <a:bodyPr/>
+          <a:lstStyle/>
+          <a:p>
+            <a:endParaRPr lang="en-US"/>
+          </a:p>
+        </p:txBody>
+      </p:sp>
+      <p:sp>
+        <p:nvSpPr>
+          <p:cNvPr id="30" name="Shape 28"/>
+          <p:cNvSpPr/>
+          <p:nvPr/>
+        </p:nvSpPr>
+        <p:spPr>
+          <a:xfrm>
+            <a:off x="2798064" y="1883664"/>
+            <a:ext cx="0" cy="91440"/>
+          </a:xfrm>
+          <a:prstGeom prst="line">
+            <a:avLst/>
+          </a:prstGeom>
+          <a:noFill/>
+          <a:ln w="6350">
+            <a:solidFill>
+              <a:srgbClr val="E8E8E8"/>
+            </a:solidFill>
+            <a:prstDash val="dot"/>
+          </a:ln>
+        </p:spPr>
+        <p:txBody>
+          <a:bodyPr/>
+          <a:lstStyle/>
+          <a:p>
+            <a:endParaRPr lang="en-US"/>
+          </a:p>
+        </p:txBody>
+      </p:sp>
+      <p:sp>
+        <p:nvSpPr>
+          <p:cNvPr id="31" name="Shape 29"/>
+          <p:cNvSpPr/>
+          <p:nvPr/>
+        </p:nvSpPr>
+        <p:spPr>
+          <a:xfrm>
+            <a:off x="2176272" y="1975104"/>
+            <a:ext cx="566928" cy="128016"/>
+          </a:xfrm>
+          <a:prstGeom prst="roundRect">
+            <a:avLst>
+              <a:gd name="adj" fmla="val 14286"/>
+            </a:avLst>
+          </a:prstGeom>
+          <a:solidFill>
+            <a:srgbClr val="FAFAFA"/>
+          </a:solidFill>
+          <a:ln w="5080">
+            <a:solidFill>
+              <a:srgbClr val="E8E8E8"/>
+            </a:solidFill>
+            <a:prstDash val="solid"/>
+          </a:ln>
+        </p:spPr>
+        <p:txBody>
+          <a:bodyPr/>
+          <a:lstStyle/>
+          <a:p>
+            <a:endParaRPr lang="en-US"/>
+          </a:p>
+        </p:txBody>
+      </p:sp>
+      <p:sp>
+        <p:nvSpPr>
+          <p:cNvPr id="32" name="Text 30"/>
+          <p:cNvSpPr/>
+          <p:nvPr/>
+        </p:nvSpPr>
+        <p:spPr>
+          <a:xfrm>
+            <a:off x="2176272" y="1975104"/>
+            <a:ext cx="566928" cy="128016"/>
+          </a:xfrm>
+          <a:prstGeom prst="rect">
+            <a:avLst/>
+          </a:prstGeom>
+          <a:noFill/>
+          <a:ln/>
+        </p:spPr>
+        <p:txBody>
+          <a:bodyPr wrap="square" lIns="0" tIns="0" rIns="0" bIns="0" rtlCol="0" anchor="ctr"/>
+          <a:lstStyle/>
+          <a:p>
+            <a:pPr marL="0" indent="0" algn="ctr">
+              <a:buNone/>
+            </a:pPr>
+            <a:r>
+              <a:rPr lang="en-US" sz="550" b="1" dirty="0">
+                <a:solidFill>
+                  <a:srgbClr val="00897B"/>
+                </a:solidFill>
+                <a:latin typeface="Calibri" pitchFamily="34" charset="0"/>
+                <a:ea typeface="Calibri" pitchFamily="34" charset="-122"/>
+                <a:cs typeface="Calibri" pitchFamily="34" charset="-120"/>
+              </a:rPr>
+              <a:t>Content</a:t>
+            </a:r>
+            <a:endParaRPr lang="en-US" sz="550" dirty="0"/>
+          </a:p>
+        </p:txBody>
+      </p:sp>
+      <p:sp>
+        <p:nvSpPr>
+          <p:cNvPr id="33" name="Shape 31"/>
+          <p:cNvSpPr/>
+          <p:nvPr/>
+        </p:nvSpPr>
+        <p:spPr>
+          <a:xfrm>
+            <a:off x="2752344" y="2039112"/>
+            <a:ext cx="91440" cy="0"/>
+          </a:xfrm>
+          <a:prstGeom prst="line">
+            <a:avLst/>
+          </a:prstGeom>
+          <a:noFill/>
+          <a:ln w="7620">
+            <a:solidFill>
+              <a:srgbClr val="BDBDBD"/>
+            </a:solidFill>
+            <a:prstDash val="solid"/>
+            <a:tailEnd type="triangle"/>
+          </a:ln>
+        </p:spPr>
+        <p:txBody>
+          <a:bodyPr/>
+          <a:lstStyle/>
+          <a:p>
+            <a:endParaRPr lang="en-US"/>
+          </a:p>
+        </p:txBody>
+      </p:sp>
+      <p:sp>
+        <p:nvSpPr>
+          <p:cNvPr id="34" name="Shape 32"/>
+          <p:cNvSpPr/>
+          <p:nvPr/>
+        </p:nvSpPr>
+        <p:spPr>
+          <a:xfrm>
+            <a:off x="2852928" y="1975104"/>
+            <a:ext cx="566928" cy="128016"/>
+          </a:xfrm>
+          <a:prstGeom prst="roundRect">
+            <a:avLst>
+              <a:gd name="adj" fmla="val 14286"/>
+            </a:avLst>
+          </a:prstGeom>
+          <a:solidFill>
+            <a:srgbClr val="FAFAFA"/>
+          </a:solidFill>
+          <a:ln w="5080">
+            <a:solidFill>
+              <a:srgbClr val="E8E8E8"/>
+            </a:solidFill>
+            <a:prstDash val="solid"/>
+          </a:ln>
+        </p:spPr>
+        <p:txBody>
+          <a:bodyPr/>
+          <a:lstStyle/>
+          <a:p>
+            <a:endParaRPr lang="en-US"/>
+          </a:p>
+        </p:txBody>
+      </p:sp>
+      <p:sp>
+        <p:nvSpPr>
+          <p:cNvPr id="35" name="Text 33"/>
+          <p:cNvSpPr/>
+          <p:nvPr/>
+        </p:nvSpPr>
+        <p:spPr>
+          <a:xfrm>
+            <a:off x="2852928" y="1975104"/>
+            <a:ext cx="566928" cy="128016"/>
+          </a:xfrm>
+          <a:prstGeom prst="rect">
+            <a:avLst/>
+          </a:prstGeom>
+          <a:noFill/>
+          <a:ln/>
+        </p:spPr>
+        <p:txBody>
+          <a:bodyPr wrap="square" lIns="0" tIns="0" rIns="0" bIns="0" rtlCol="0" anchor="ctr"/>
+          <a:lstStyle/>
+          <a:p>
+            <a:pPr marL="0" indent="0" algn="ctr">
+              <a:buNone/>
+            </a:pPr>
+            <a:r>
+              <a:rPr lang="en-US" sz="550" b="1" dirty="0">
+                <a:solidFill>
+                  <a:srgbClr val="00897B"/>
+                </a:solidFill>
+                <a:latin typeface="Calibri" pitchFamily="34" charset="0"/>
+                <a:ea typeface="Calibri" pitchFamily="34" charset="-122"/>
+                <a:cs typeface="Calibri" pitchFamily="34" charset="-120"/>
+              </a:rPr>
+              <a:t>Functional</a:t>
+            </a:r>
+            <a:endParaRPr lang="en-US" sz="550" dirty="0"/>
+          </a:p>
+        </p:txBody>
+      </p:sp>
+      <p:sp>
+        <p:nvSpPr>
+          <p:cNvPr id="36" name="Shape 34"/>
+          <p:cNvSpPr/>
+          <p:nvPr/>
+        </p:nvSpPr>
+        <p:spPr>
+          <a:xfrm>
+            <a:off x="5870448" y="1883664"/>
+            <a:ext cx="0" cy="91440"/>
+          </a:xfrm>
+          <a:prstGeom prst="line">
+            <a:avLst/>
+          </a:prstGeom>
+          <a:noFill/>
+          <a:ln w="6350">
+            <a:solidFill>
+              <a:srgbClr val="E8E8E8"/>
+            </a:solidFill>
+            <a:prstDash val="dot"/>
+          </a:ln>
+        </p:spPr>
+        <p:txBody>
+          <a:bodyPr/>
+          <a:lstStyle/>
+          <a:p>
+            <a:endParaRPr lang="en-US"/>
+          </a:p>
+        </p:txBody>
+      </p:sp>
+      <p:sp>
+        <p:nvSpPr>
+          <p:cNvPr id="37" name="Text 35"/>
+          <p:cNvSpPr/>
+          <p:nvPr/>
+        </p:nvSpPr>
+        <p:spPr>
+          <a:xfrm>
+            <a:off x="5248656" y="1975104"/>
+            <a:ext cx="256032" cy="128016"/>
+          </a:xfrm>
+          <a:prstGeom prst="rect">
+            <a:avLst/>
+          </a:prstGeom>
+          <a:noFill/>
+          <a:ln/>
+        </p:spPr>
+        <p:txBody>
+          <a:bodyPr wrap="square" lIns="0" tIns="0" rIns="0" bIns="0" rtlCol="0" anchor="ctr"/>
+          <a:lstStyle/>
+          <a:p>
+            <a:pPr marL="0" indent="0">
+              <a:buNone/>
+            </a:pPr>
+            <a:r>
+              <a:rPr lang="en-US" sz="500" b="1" dirty="0">
+                <a:solidFill>
+                  <a:srgbClr val="78909C"/>
+                </a:solidFill>
+                <a:latin typeface="Calibri" pitchFamily="34" charset="0"/>
+                <a:ea typeface="Calibri" pitchFamily="34" charset="-122"/>
+                <a:cs typeface="Calibri" pitchFamily="34" charset="-120"/>
+              </a:rPr>
+              <a:t>MCP</a:t>
+            </a:r>
+            <a:endParaRPr lang="en-US" sz="500" dirty="0"/>
+          </a:p>
+        </p:txBody>
+      </p:sp>
+      <p:sp>
+        <p:nvSpPr>
+          <p:cNvPr id="38" name="Shape 36"/>
+          <p:cNvSpPr/>
+          <p:nvPr/>
+        </p:nvSpPr>
+        <p:spPr>
+          <a:xfrm>
+            <a:off x="5504688" y="1975104"/>
+            <a:ext cx="256032" cy="128016"/>
+          </a:xfrm>
+          <a:prstGeom prst="roundRect">
+            <a:avLst>
+              <a:gd name="adj" fmla="val 14286"/>
+            </a:avLst>
+          </a:prstGeom>
+          <a:solidFill>
+            <a:srgbClr val="FAFAFA"/>
+          </a:solidFill>
+          <a:ln w="5080">
+            <a:solidFill>
+              <a:srgbClr val="E8E8E8"/>
+            </a:solidFill>
+            <a:prstDash val="solid"/>
+          </a:ln>
+        </p:spPr>
+        <p:txBody>
+          <a:bodyPr/>
+          <a:lstStyle/>
+          <a:p>
+            <a:endParaRPr lang="en-US"/>
+          </a:p>
+        </p:txBody>
+      </p:sp>
+      <p:sp>
+        <p:nvSpPr>
+          <p:cNvPr id="39" name="Text 37"/>
+          <p:cNvSpPr/>
+          <p:nvPr/>
+        </p:nvSpPr>
+        <p:spPr>
+          <a:xfrm>
+            <a:off x="5504688" y="1975104"/>
+            <a:ext cx="256032" cy="128016"/>
+          </a:xfrm>
+          <a:prstGeom prst="rect">
+            <a:avLst/>
+          </a:prstGeom>
+          <a:noFill/>
+          <a:ln/>
+        </p:spPr>
+        <p:txBody>
+          <a:bodyPr wrap="square" lIns="0" tIns="0" rIns="0" bIns="0" rtlCol="0" anchor="ctr"/>
+          <a:lstStyle/>
+          <a:p>
+            <a:pPr marL="0" indent="0" algn="ctr">
+              <a:buNone/>
+            </a:pPr>
+            <a:r>
+              <a:rPr lang="en-US" sz="550" b="1" dirty="0">
+                <a:solidFill>
+                  <a:srgbClr val="00897B"/>
+                </a:solidFill>
+                <a:latin typeface="Calibri" pitchFamily="34" charset="0"/>
+                <a:ea typeface="Calibri" pitchFamily="34" charset="-122"/>
+                <a:cs typeface="Calibri" pitchFamily="34" charset="-120"/>
+              </a:rPr>
+              <a:t>DEV</a:t>
+            </a:r>
+            <a:endParaRPr lang="en-US" sz="550" dirty="0"/>
+          </a:p>
+        </p:txBody>
+      </p:sp>
+      <p:sp>
+        <p:nvSpPr>
+          <p:cNvPr id="40" name="Shape 38"/>
+          <p:cNvSpPr/>
+          <p:nvPr/>
+        </p:nvSpPr>
+        <p:spPr>
+          <a:xfrm>
+            <a:off x="5769864" y="2039112"/>
+            <a:ext cx="91440" cy="0"/>
+          </a:xfrm>
+          <a:prstGeom prst="line">
+            <a:avLst/>
+          </a:prstGeom>
+          <a:noFill/>
+          <a:ln w="7620">
+            <a:solidFill>
+              <a:srgbClr val="BDBDBD"/>
+            </a:solidFill>
+            <a:prstDash val="solid"/>
+            <a:tailEnd type="triangle"/>
+          </a:ln>
+        </p:spPr>
+        <p:txBody>
+          <a:bodyPr/>
+          <a:lstStyle/>
+          <a:p>
+            <a:endParaRPr lang="en-US"/>
+          </a:p>
+        </p:txBody>
+      </p:sp>
+      <p:sp>
+        <p:nvSpPr>
+          <p:cNvPr id="41" name="Shape 39"/>
+          <p:cNvSpPr/>
+          <p:nvPr/>
+        </p:nvSpPr>
+        <p:spPr>
+          <a:xfrm>
+            <a:off x="5870448" y="1975104"/>
+            <a:ext cx="256032" cy="128016"/>
+          </a:xfrm>
+          <a:prstGeom prst="roundRect">
+            <a:avLst>
+              <a:gd name="adj" fmla="val 14286"/>
+            </a:avLst>
+          </a:prstGeom>
+          <a:solidFill>
+            <a:srgbClr val="FAFAFA"/>
+          </a:solidFill>
+          <a:ln w="5080">
+            <a:solidFill>
+              <a:srgbClr val="E8E8E8"/>
+            </a:solidFill>
+            <a:prstDash val="solid"/>
+          </a:ln>
+        </p:spPr>
+        <p:txBody>
+          <a:bodyPr/>
+          <a:lstStyle/>
+          <a:p>
+            <a:endParaRPr lang="en-US"/>
+          </a:p>
+        </p:txBody>
+      </p:sp>
+      <p:sp>
+        <p:nvSpPr>
+          <p:cNvPr id="42" name="Text 40"/>
+          <p:cNvSpPr/>
+          <p:nvPr/>
+        </p:nvSpPr>
+        <p:spPr>
+          <a:xfrm>
+            <a:off x="5870448" y="1975104"/>
+            <a:ext cx="256032" cy="128016"/>
+          </a:xfrm>
+          <a:prstGeom prst="rect">
+            <a:avLst/>
+          </a:prstGeom>
+          <a:noFill/>
+          <a:ln/>
+        </p:spPr>
+        <p:txBody>
+          <a:bodyPr wrap="square" lIns="0" tIns="0" rIns="0" bIns="0" rtlCol="0" anchor="ctr"/>
+          <a:lstStyle/>
+          <a:p>
+            <a:pPr marL="0" indent="0" algn="ctr">
+              <a:buNone/>
+            </a:pPr>
+            <a:r>
+              <a:rPr lang="en-US" sz="550" b="1" dirty="0">
+                <a:solidFill>
+                  <a:srgbClr val="00897B"/>
+                </a:solidFill>
+                <a:latin typeface="Calibri" pitchFamily="34" charset="0"/>
+                <a:ea typeface="Calibri" pitchFamily="34" charset="-122"/>
+                <a:cs typeface="Calibri" pitchFamily="34" charset="-120"/>
+              </a:rPr>
+              <a:t>UAT</a:t>
+            </a:r>
+            <a:endParaRPr lang="en-US" sz="550" dirty="0"/>
+          </a:p>
+        </p:txBody>
+      </p:sp>
+      <p:sp>
+        <p:nvSpPr>
+          <p:cNvPr id="43" name="Shape 41"/>
+          <p:cNvSpPr/>
+          <p:nvPr/>
+        </p:nvSpPr>
+        <p:spPr>
+          <a:xfrm>
+            <a:off x="6135624" y="2039112"/>
+            <a:ext cx="91440" cy="0"/>
+          </a:xfrm>
+          <a:prstGeom prst="line">
+            <a:avLst/>
+          </a:prstGeom>
+          <a:noFill/>
+          <a:ln w="7620">
+            <a:solidFill>
+              <a:srgbClr val="BDBDBD"/>
+            </a:solidFill>
+            <a:prstDash val="solid"/>
+            <a:tailEnd type="triangle"/>
+          </a:ln>
+        </p:spPr>
+        <p:txBody>
+          <a:bodyPr/>
+          <a:lstStyle/>
+          <a:p>
+            <a:endParaRPr lang="en-US"/>
+          </a:p>
+        </p:txBody>
+      </p:sp>
+      <p:sp>
+        <p:nvSpPr>
+          <p:cNvPr id="44" name="Shape 42"/>
+          <p:cNvSpPr/>
+          <p:nvPr/>
+        </p:nvSpPr>
+        <p:spPr>
+          <a:xfrm>
+            <a:off x="6236208" y="1975104"/>
+            <a:ext cx="256032" cy="128016"/>
+          </a:xfrm>
+          <a:prstGeom prst="roundRect">
+            <a:avLst>
+              <a:gd name="adj" fmla="val 14286"/>
+            </a:avLst>
+          </a:prstGeom>
+          <a:solidFill>
+            <a:srgbClr val="FAFAFA"/>
+          </a:solidFill>
+          <a:ln w="5080">
+            <a:solidFill>
+              <a:srgbClr val="E8E8E8"/>
+            </a:solidFill>
+            <a:prstDash val="solid"/>
+          </a:ln>
+        </p:spPr>
+        <p:txBody>
+          <a:bodyPr/>
+          <a:lstStyle/>
+          <a:p>
+            <a:endParaRPr lang="en-US"/>
+          </a:p>
+        </p:txBody>
+      </p:sp>
+      <p:sp>
+        <p:nvSpPr>
+          <p:cNvPr id="45" name="Text 43"/>
+          <p:cNvSpPr/>
+          <p:nvPr/>
+        </p:nvSpPr>
+        <p:spPr>
+          <a:xfrm>
+            <a:off x="6236208" y="1975104"/>
+            <a:ext cx="256032" cy="128016"/>
+          </a:xfrm>
+          <a:prstGeom prst="rect">
+            <a:avLst/>
+          </a:prstGeom>
+          <a:noFill/>
+          <a:ln/>
+        </p:spPr>
+        <p:txBody>
+          <a:bodyPr wrap="square" lIns="0" tIns="0" rIns="0" bIns="0" rtlCol="0" anchor="ctr"/>
+          <a:lstStyle/>
+          <a:p>
+            <a:pPr marL="0" indent="0" algn="ctr">
+              <a:buNone/>
+            </a:pPr>
+            <a:r>
+              <a:rPr lang="en-US" sz="550" b="1" dirty="0">
+                <a:solidFill>
+                  <a:srgbClr val="00897B"/>
+                </a:solidFill>
+                <a:latin typeface="Calibri" pitchFamily="34" charset="0"/>
+                <a:ea typeface="Calibri" pitchFamily="34" charset="-122"/>
+                <a:cs typeface="Calibri" pitchFamily="34" charset="-120"/>
+              </a:rPr>
+              <a:t>PROD</a:t>
+            </a:r>
+            <a:endParaRPr lang="en-US" sz="550" dirty="0"/>
+          </a:p>
+        </p:txBody>
+      </p:sp>
+      <p:sp>
+        <p:nvSpPr>
+          <p:cNvPr id="46" name="Text 44"/>
+          <p:cNvSpPr/>
+          <p:nvPr/>
+        </p:nvSpPr>
+        <p:spPr>
+          <a:xfrm>
+            <a:off x="5248656" y="2157984"/>
+            <a:ext cx="256032" cy="128016"/>
+          </a:xfrm>
+          <a:prstGeom prst="rect">
+            <a:avLst/>
+          </a:prstGeom>
+          <a:noFill/>
+          <a:ln/>
+        </p:spPr>
+        <p:txBody>
+          <a:bodyPr wrap="square" lIns="0" tIns="0" rIns="0" bIns="0" rtlCol="0" anchor="ctr"/>
+          <a:lstStyle/>
+          <a:p>
+            <a:pPr marL="0" indent="0">
+              <a:buNone/>
+            </a:pPr>
+            <a:r>
+              <a:rPr lang="en-US" sz="500" b="1" dirty="0">
+                <a:solidFill>
+                  <a:srgbClr val="78909C"/>
+                </a:solidFill>
+                <a:latin typeface="Calibri" pitchFamily="34" charset="0"/>
+                <a:ea typeface="Calibri" pitchFamily="34" charset="-122"/>
+                <a:cs typeface="Calibri" pitchFamily="34" charset="-120"/>
+              </a:rPr>
+              <a:t>DOC</a:t>
+            </a:r>
+            <a:endParaRPr lang="en-US" sz="500" dirty="0"/>
+          </a:p>
+        </p:txBody>
+      </p:sp>
+      <p:sp>
+        <p:nvSpPr>
+          <p:cNvPr id="47" name="Shape 45"/>
+          <p:cNvSpPr/>
+          <p:nvPr/>
+        </p:nvSpPr>
+        <p:spPr>
+          <a:xfrm>
+            <a:off x="5504688" y="2157984"/>
+            <a:ext cx="256032" cy="128016"/>
+          </a:xfrm>
+          <a:prstGeom prst="roundRect">
+            <a:avLst>
+              <a:gd name="adj" fmla="val 14286"/>
+            </a:avLst>
+          </a:prstGeom>
+          <a:solidFill>
+            <a:srgbClr val="FAFAFA"/>
+          </a:solidFill>
+          <a:ln w="5080">
+            <a:solidFill>
+              <a:srgbClr val="E8E8E8"/>
+            </a:solidFill>
+            <a:prstDash val="solid"/>
+          </a:ln>
+        </p:spPr>
+        <p:txBody>
+          <a:bodyPr/>
+          <a:lstStyle/>
+          <a:p>
+            <a:endParaRPr lang="en-US"/>
+          </a:p>
+        </p:txBody>
+      </p:sp>
+      <p:sp>
+        <p:nvSpPr>
+          <p:cNvPr id="48" name="Text 46"/>
+          <p:cNvSpPr/>
+          <p:nvPr/>
+        </p:nvSpPr>
+        <p:spPr>
+          <a:xfrm>
+            <a:off x="5504688" y="2157984"/>
+            <a:ext cx="256032" cy="128016"/>
+          </a:xfrm>
+          <a:prstGeom prst="rect">
+            <a:avLst/>
+          </a:prstGeom>
+          <a:noFill/>
+          <a:ln/>
+        </p:spPr>
+        <p:txBody>
+          <a:bodyPr wrap="square" lIns="0" tIns="0" rIns="0" bIns="0" rtlCol="0" anchor="ctr"/>
+          <a:lstStyle/>
+          <a:p>
+            <a:pPr marL="0" indent="0" algn="ctr">
+              <a:buNone/>
+            </a:pPr>
+            <a:r>
+              <a:rPr lang="en-US" sz="550" b="1" dirty="0">
+                <a:solidFill>
+                  <a:srgbClr val="546E7A"/>
+                </a:solidFill>
+                <a:latin typeface="Calibri" pitchFamily="34" charset="0"/>
+                <a:ea typeface="Calibri" pitchFamily="34" charset="-122"/>
+                <a:cs typeface="Calibri" pitchFamily="34" charset="-120"/>
+              </a:rPr>
+              <a:t>Ingest</a:t>
+            </a:r>
+            <a:endParaRPr lang="en-US" sz="550" dirty="0"/>
+          </a:p>
+        </p:txBody>
+      </p:sp>
+      <p:sp>
+        <p:nvSpPr>
+          <p:cNvPr id="49" name="Shape 47"/>
+          <p:cNvSpPr/>
+          <p:nvPr/>
+        </p:nvSpPr>
+        <p:spPr>
+          <a:xfrm>
+            <a:off x="5769864" y="2221992"/>
+            <a:ext cx="91440" cy="0"/>
+          </a:xfrm>
+          <a:prstGeom prst="line">
+            <a:avLst/>
+          </a:prstGeom>
+          <a:noFill/>
+          <a:ln w="7620">
+            <a:solidFill>
+              <a:srgbClr val="BDBDBD"/>
+            </a:solidFill>
+            <a:prstDash val="solid"/>
+            <a:tailEnd type="triangle"/>
+          </a:ln>
+        </p:spPr>
+        <p:txBody>
+          <a:bodyPr/>
+          <a:lstStyle/>
+          <a:p>
+            <a:endParaRPr lang="en-US"/>
+          </a:p>
+        </p:txBody>
+      </p:sp>
+      <p:sp>
+        <p:nvSpPr>
+          <p:cNvPr id="50" name="Shape 48"/>
+          <p:cNvSpPr/>
+          <p:nvPr/>
+        </p:nvSpPr>
+        <p:spPr>
+          <a:xfrm>
+            <a:off x="5870448" y="2157984"/>
+            <a:ext cx="256032" cy="128016"/>
+          </a:xfrm>
+          <a:prstGeom prst="roundRect">
+            <a:avLst>
+              <a:gd name="adj" fmla="val 14286"/>
+            </a:avLst>
+          </a:prstGeom>
+          <a:solidFill>
+            <a:srgbClr val="FAFAFA"/>
+          </a:solidFill>
+          <a:ln w="5080">
+            <a:solidFill>
+              <a:srgbClr val="E8E8E8"/>
+            </a:solidFill>
+            <a:prstDash val="solid"/>
+          </a:ln>
+        </p:spPr>
+        <p:txBody>
+          <a:bodyPr/>
+          <a:lstStyle/>
+          <a:p>
+            <a:endParaRPr lang="en-US"/>
+          </a:p>
+        </p:txBody>
+      </p:sp>
+      <p:sp>
+        <p:nvSpPr>
+          <p:cNvPr id="51" name="Text 49"/>
+          <p:cNvSpPr/>
+          <p:nvPr/>
+        </p:nvSpPr>
+        <p:spPr>
+          <a:xfrm>
+            <a:off x="5870448" y="2157984"/>
+            <a:ext cx="256032" cy="128016"/>
+          </a:xfrm>
+          <a:prstGeom prst="rect">
+            <a:avLst/>
+          </a:prstGeom>
+          <a:noFill/>
+          <a:ln/>
+        </p:spPr>
+        <p:txBody>
+          <a:bodyPr wrap="square" lIns="0" tIns="0" rIns="0" bIns="0" rtlCol="0" anchor="ctr"/>
+          <a:lstStyle/>
+          <a:p>
+            <a:pPr marL="0" indent="0" algn="ctr">
+              <a:buNone/>
+            </a:pPr>
+            <a:r>
+              <a:rPr lang="en-US" sz="550" b="1" dirty="0">
+                <a:solidFill>
+                  <a:srgbClr val="546E7A"/>
+                </a:solidFill>
+                <a:latin typeface="Calibri" pitchFamily="34" charset="0"/>
+                <a:ea typeface="Calibri" pitchFamily="34" charset="-122"/>
+                <a:cs typeface="Calibri" pitchFamily="34" charset="-120"/>
+              </a:rPr>
+              <a:t>Review</a:t>
+            </a:r>
+            <a:endParaRPr lang="en-US" sz="550" dirty="0"/>
+          </a:p>
+        </p:txBody>
+      </p:sp>
+      <p:sp>
+        <p:nvSpPr>
+          <p:cNvPr id="52" name="Shape 50"/>
+          <p:cNvSpPr/>
+          <p:nvPr/>
+        </p:nvSpPr>
+        <p:spPr>
+          <a:xfrm>
+            <a:off x="6135624" y="2221992"/>
+            <a:ext cx="91440" cy="0"/>
+          </a:xfrm>
+          <a:prstGeom prst="line">
+            <a:avLst/>
+          </a:prstGeom>
+          <a:noFill/>
+          <a:ln w="7620">
+            <a:solidFill>
+              <a:srgbClr val="BDBDBD"/>
+            </a:solidFill>
+            <a:prstDash val="solid"/>
+            <a:tailEnd type="triangle"/>
+          </a:ln>
+        </p:spPr>
+        <p:txBody>
+          <a:bodyPr/>
+          <a:lstStyle/>
+          <a:p>
+            <a:endParaRPr lang="en-US"/>
+          </a:p>
+        </p:txBody>
+      </p:sp>
+      <p:sp>
+        <p:nvSpPr>
+          <p:cNvPr id="53" name="Shape 51"/>
+          <p:cNvSpPr/>
+          <p:nvPr/>
+        </p:nvSpPr>
+        <p:spPr>
+          <a:xfrm>
+            <a:off x="6236208" y="2157984"/>
+            <a:ext cx="256032" cy="128016"/>
+          </a:xfrm>
+          <a:prstGeom prst="roundRect">
+            <a:avLst>
+              <a:gd name="adj" fmla="val 14286"/>
+            </a:avLst>
+          </a:prstGeom>
+          <a:solidFill>
+            <a:srgbClr val="FAFAFA"/>
+          </a:solidFill>
+          <a:ln w="5080">
+            <a:solidFill>
+              <a:srgbClr val="E8E8E8"/>
+            </a:solidFill>
+            <a:prstDash val="solid"/>
+          </a:ln>
+        </p:spPr>
+        <p:txBody>
+          <a:bodyPr/>
+          <a:lstStyle/>
+          <a:p>
+            <a:endParaRPr lang="en-US"/>
+          </a:p>
+        </p:txBody>
+      </p:sp>
+      <p:sp>
+        <p:nvSpPr>
+          <p:cNvPr id="54" name="Text 52"/>
+          <p:cNvSpPr/>
+          <p:nvPr/>
+        </p:nvSpPr>
+        <p:spPr>
+          <a:xfrm>
+            <a:off x="6236208" y="2157984"/>
+            <a:ext cx="256032" cy="128016"/>
+          </a:xfrm>
+          <a:prstGeom prst="rect">
+            <a:avLst/>
+          </a:prstGeom>
+          <a:noFill/>
+          <a:ln/>
+        </p:spPr>
+        <p:txBody>
+          <a:bodyPr wrap="square" lIns="0" tIns="0" rIns="0" bIns="0" rtlCol="0" anchor="ctr"/>
+          <a:lstStyle/>
+          <a:p>
+            <a:pPr marL="0" indent="0" algn="ctr">
+              <a:buNone/>
+            </a:pPr>
+            <a:r>
+              <a:rPr lang="en-US" sz="550" b="1" dirty="0">
+                <a:solidFill>
+                  <a:srgbClr val="546E7A"/>
+                </a:solidFill>
+                <a:latin typeface="Calibri" pitchFamily="34" charset="0"/>
+                <a:ea typeface="Calibri" pitchFamily="34" charset="-122"/>
+                <a:cs typeface="Calibri" pitchFamily="34" charset="-120"/>
+              </a:rPr>
+              <a:t>Improve</a:t>
+            </a:r>
+            <a:endParaRPr lang="en-US" sz="550" dirty="0"/>
+          </a:p>
+        </p:txBody>
+      </p:sp>
+      <p:sp>
+        <p:nvSpPr>
+          <p:cNvPr id="55" name="Shape 53"/>
+          <p:cNvSpPr/>
+          <p:nvPr/>
+        </p:nvSpPr>
+        <p:spPr>
+          <a:xfrm>
+            <a:off x="2450592" y="1371600"/>
+            <a:ext cx="0" cy="0"/>
+          </a:xfrm>
+          <a:prstGeom prst="line">
+            <a:avLst/>
+          </a:prstGeom>
+          <a:noFill/>
+          <a:ln w="10160">
+            <a:solidFill>
+              <a:srgbClr val="EF5350"/>
+            </a:solidFill>
+            <a:prstDash val="dash"/>
+          </a:ln>
+        </p:spPr>
+        <p:txBody>
+          <a:bodyPr/>
+          <a:lstStyle/>
+          <a:p>
+            <a:endParaRPr lang="en-US"/>
+          </a:p>
+        </p:txBody>
+      </p:sp>
+      <p:sp>
+        <p:nvSpPr>
+          <p:cNvPr id="56" name="Shape 54"/>
+          <p:cNvSpPr/>
+          <p:nvPr/>
+        </p:nvSpPr>
+        <p:spPr>
+          <a:xfrm>
+            <a:off x="1261872" y="1207008"/>
+            <a:ext cx="1188720" cy="0"/>
+          </a:xfrm>
+          <a:prstGeom prst="line">
+            <a:avLst/>
+          </a:prstGeom>
+          <a:noFill/>
+          <a:ln w="10160">
+            <a:solidFill>
+              <a:srgbClr val="EF5350"/>
+            </a:solidFill>
+            <a:prstDash val="dash"/>
+          </a:ln>
+        </p:spPr>
+        <p:txBody>
+          <a:bodyPr/>
+          <a:lstStyle/>
+          <a:p>
+            <a:endParaRPr lang="en-US"/>
+          </a:p>
+        </p:txBody>
+      </p:sp>
+      <p:sp>
+        <p:nvSpPr>
+          <p:cNvPr id="57" name="Shape 55"/>
+          <p:cNvSpPr/>
+          <p:nvPr/>
+        </p:nvSpPr>
+        <p:spPr>
+          <a:xfrm>
+            <a:off x="1261872" y="1207008"/>
+            <a:ext cx="0" cy="164592"/>
+          </a:xfrm>
+          <a:prstGeom prst="line">
+            <a:avLst/>
+          </a:prstGeom>
+          <a:noFill/>
+          <a:ln w="10160">
+            <a:solidFill>
+              <a:srgbClr val="EF5350"/>
+            </a:solidFill>
+            <a:prstDash val="dash"/>
+            <a:tailEnd type="triangle"/>
+          </a:ln>
+        </p:spPr>
+        <p:txBody>
+          <a:bodyPr/>
+          <a:lstStyle/>
+          <a:p>
+            <a:endParaRPr lang="en-US"/>
+          </a:p>
+        </p:txBody>
+      </p:sp>
+      <p:sp>
+        <p:nvSpPr>
+          <p:cNvPr id="58" name="Text 56"/>
+          <p:cNvSpPr/>
+          <p:nvPr/>
+        </p:nvSpPr>
+        <p:spPr>
+          <a:xfrm>
+            <a:off x="1298448" y="1088136"/>
+            <a:ext cx="731520" cy="118872"/>
+          </a:xfrm>
+          <a:prstGeom prst="rect">
+            <a:avLst/>
+          </a:prstGeom>
+          <a:noFill/>
+          <a:ln/>
+        </p:spPr>
+        <p:txBody>
+          <a:bodyPr wrap="square" lIns="0" tIns="0" rIns="0" bIns="0" rtlCol="0" anchor="ctr"/>
+          <a:lstStyle/>
+          <a:p>
+            <a:pPr marL="0" indent="0">
+              <a:buNone/>
+            </a:pPr>
+            <a:r>
+              <a:rPr lang="en-US" sz="550" i="1" dirty="0">
+                <a:solidFill>
+                  <a:srgbClr val="EF5350"/>
+                </a:solidFill>
+                <a:latin typeface="Calibri" pitchFamily="34" charset="0"/>
+                <a:ea typeface="Calibri" pitchFamily="34" charset="-122"/>
+                <a:cs typeface="Calibri" pitchFamily="34" charset="-120"/>
+              </a:rPr>
+              <a:t>Rejected</a:t>
+            </a:r>
+            <a:endParaRPr lang="en-US" sz="550" dirty="0"/>
+          </a:p>
+        </p:txBody>
+      </p:sp>
+      <p:sp>
+        <p:nvSpPr>
+          <p:cNvPr id="59" name="Shape 57"/>
+          <p:cNvSpPr/>
+          <p:nvPr/>
+        </p:nvSpPr>
+        <p:spPr>
+          <a:xfrm>
+            <a:off x="7655357" y="1371600"/>
+            <a:ext cx="0" cy="0"/>
+          </a:xfrm>
+          <a:prstGeom prst="line">
+            <a:avLst/>
+          </a:prstGeom>
+          <a:noFill/>
+          <a:ln w="10160">
+            <a:solidFill>
+              <a:srgbClr val="F57F17"/>
+            </a:solidFill>
+            <a:prstDash val="dash"/>
+          </a:ln>
+        </p:spPr>
+        <p:txBody>
+          <a:bodyPr/>
+          <a:lstStyle/>
+          <a:p>
+            <a:endParaRPr lang="en-US"/>
+          </a:p>
+        </p:txBody>
+      </p:sp>
+      <p:sp>
+        <p:nvSpPr>
+          <p:cNvPr id="60" name="Shape 58"/>
+          <p:cNvSpPr/>
+          <p:nvPr/>
+        </p:nvSpPr>
+        <p:spPr>
+          <a:xfrm>
+            <a:off x="3046781" y="1060704"/>
+            <a:ext cx="4608576" cy="0"/>
+          </a:xfrm>
+          <a:prstGeom prst="line">
+            <a:avLst/>
+          </a:prstGeom>
+          <a:noFill/>
+          <a:ln w="10160">
+            <a:solidFill>
+              <a:srgbClr val="F57F17"/>
+            </a:solidFill>
+            <a:prstDash val="dash"/>
+          </a:ln>
+        </p:spPr>
+        <p:txBody>
+          <a:bodyPr/>
+          <a:lstStyle/>
+          <a:p>
+            <a:endParaRPr lang="en-US"/>
+          </a:p>
+        </p:txBody>
+      </p:sp>
+      <p:sp>
+        <p:nvSpPr>
+          <p:cNvPr id="61" name="Shape 59"/>
+          <p:cNvSpPr/>
+          <p:nvPr/>
+        </p:nvSpPr>
+        <p:spPr>
+          <a:xfrm>
+            <a:off x="3046781" y="1060704"/>
+            <a:ext cx="0" cy="310896"/>
+          </a:xfrm>
+          <a:prstGeom prst="line">
+            <a:avLst/>
+          </a:prstGeom>
+          <a:noFill/>
+          <a:ln w="10160">
+            <a:solidFill>
+              <a:srgbClr val="F57F17"/>
+            </a:solidFill>
+            <a:prstDash val="dash"/>
+            <a:tailEnd type="triangle"/>
+          </a:ln>
+        </p:spPr>
+        <p:txBody>
+          <a:bodyPr/>
+          <a:lstStyle/>
+          <a:p>
+            <a:endParaRPr lang="en-US"/>
+          </a:p>
+        </p:txBody>
+      </p:sp>
+      <p:sp>
+        <p:nvSpPr>
+          <p:cNvPr id="62" name="Text 60"/>
+          <p:cNvSpPr/>
+          <p:nvPr/>
+        </p:nvSpPr>
+        <p:spPr>
+          <a:xfrm>
+            <a:off x="4939589" y="932688"/>
+            <a:ext cx="822960" cy="118872"/>
+          </a:xfrm>
+          <a:prstGeom prst="rect">
+            <a:avLst/>
+          </a:prstGeom>
+          <a:noFill/>
+          <a:ln/>
+        </p:spPr>
+        <p:txBody>
+          <a:bodyPr wrap="square" lIns="0" tIns="0" rIns="0" bIns="0" rtlCol="0" anchor="ctr"/>
+          <a:lstStyle/>
+          <a:p>
+            <a:pPr marL="0" indent="0" algn="ctr">
+              <a:buNone/>
+            </a:pPr>
+            <a:r>
+              <a:rPr lang="en-US" sz="550" i="1" dirty="0">
+                <a:solidFill>
+                  <a:srgbClr val="F57F17"/>
+                </a:solidFill>
+                <a:latin typeface="Calibri" pitchFamily="34" charset="0"/>
+                <a:ea typeface="Calibri" pitchFamily="34" charset="-122"/>
+                <a:cs typeface="Calibri" pitchFamily="34" charset="-120"/>
+              </a:rPr>
+              <a:t>Deprecated</a:t>
+            </a:r>
+            <a:endParaRPr lang="en-US" sz="550" dirty="0"/>
+          </a:p>
+        </p:txBody>
+      </p:sp>
+      <p:sp>
+        <p:nvSpPr>
+          <p:cNvPr id="63" name="Shape 61"/>
+          <p:cNvSpPr/>
+          <p:nvPr/>
+        </p:nvSpPr>
+        <p:spPr>
+          <a:xfrm>
+            <a:off x="548640" y="2468880"/>
+            <a:ext cx="8046720" cy="0"/>
+          </a:xfrm>
+          <a:prstGeom prst="line">
+            <a:avLst/>
+          </a:prstGeom>
+          <a:noFill/>
+          <a:ln w="6350">
+            <a:solidFill>
+              <a:srgbClr val="E8E8E8"/>
+            </a:solidFill>
+            <a:prstDash val="solid"/>
+          </a:ln>
+        </p:spPr>
+        <p:txBody>
+          <a:bodyPr/>
+          <a:lstStyle/>
+          <a:p>
+            <a:endParaRPr lang="en-US"/>
+          </a:p>
+        </p:txBody>
+      </p:sp>
+      <p:sp>
+        <p:nvSpPr>
+          <p:cNvPr id="64" name="Text 62"/>
+          <p:cNvSpPr/>
+          <p:nvPr/>
+        </p:nvSpPr>
+        <p:spPr>
+          <a:xfrm>
+            <a:off x="548640" y="2596896"/>
+            <a:ext cx="3657600" cy="164592"/>
+          </a:xfrm>
+          <a:prstGeom prst="rect">
+            <a:avLst/>
+          </a:prstGeom>
+          <a:noFill/>
+          <a:ln/>
+        </p:spPr>
+        <p:txBody>
+          <a:bodyPr wrap="square" lIns="0" tIns="0" rIns="0" bIns="0" rtlCol="0" anchor="ctr"/>
+          <a:lstStyle/>
+          <a:p>
+            <a:pPr marL="0" indent="0">
+              <a:buNone/>
+            </a:pPr>
+            <a:r>
+              <a:rPr lang="en-US" sz="700" b="1" kern="0" spc="200" dirty="0">
+                <a:solidFill>
+                  <a:srgbClr val="D71E28"/>
+                </a:solidFill>
+                <a:latin typeface="Calibri" pitchFamily="34" charset="0"/>
+                <a:ea typeface="Calibri" pitchFamily="34" charset="-122"/>
+                <a:cs typeface="Calibri" pitchFamily="34" charset="-120"/>
+              </a:rPr>
+              <a:t>DEVELOPER  JOURNEY</a:t>
+            </a:r>
+            <a:endParaRPr lang="en-US" sz="700" dirty="0"/>
+          </a:p>
+        </p:txBody>
+      </p:sp>
+      <p:sp>
+        <p:nvSpPr>
+          <p:cNvPr id="65" name="Shape 63"/>
+          <p:cNvSpPr/>
+          <p:nvPr/>
+        </p:nvSpPr>
+        <p:spPr>
+          <a:xfrm>
+            <a:off x="640080" y="2852928"/>
+            <a:ext cx="1243584" cy="512064"/>
+          </a:xfrm>
+          <a:prstGeom prst="rect">
+            <a:avLst/>
+          </a:prstGeom>
+          <a:solidFill>
+            <a:srgbClr val="F5F5F5"/>
+          </a:solidFill>
+          <a:ln w="6350">
+            <a:solidFill>
+              <a:srgbClr val="E8E8E8"/>
+            </a:solidFill>
+            <a:prstDash val="solid"/>
+          </a:ln>
+          <a:effectLst>
+            <a:outerShdw blurRad="38100" dist="12700" dir="8100000" algn="bl" rotWithShape="0">
+              <a:srgbClr val="000000">
+                <a:alpha val="6000"/>
+              </a:srgbClr>
+            </a:outerShdw>
+          </a:effectLst>
+        </p:spPr>
+        <p:txBody>
+          <a:bodyPr/>
+          <a:lstStyle/>
+          <a:p>
+            <a:endParaRPr lang="en-US"/>
+          </a:p>
+        </p:txBody>
+      </p:sp>
+      <p:sp>
+        <p:nvSpPr>
+          <p:cNvPr id="66" name="Shape 64"/>
+          <p:cNvSpPr/>
+          <p:nvPr/>
+        </p:nvSpPr>
+        <p:spPr>
+          <a:xfrm>
+            <a:off x="640080" y="2852928"/>
+            <a:ext cx="1243584" cy="27432"/>
+          </a:xfrm>
+          <a:prstGeom prst="rect">
+            <a:avLst/>
+          </a:prstGeom>
+          <a:solidFill>
+            <a:srgbClr val="D71E28"/>
+          </a:solidFill>
+          <a:ln/>
+        </p:spPr>
+        <p:txBody>
+          <a:bodyPr/>
+          <a:lstStyle/>
+          <a:p>
+            <a:endParaRPr lang="en-US"/>
+          </a:p>
+        </p:txBody>
+      </p:sp>
+      <p:sp>
+        <p:nvSpPr>
+          <p:cNvPr id="67" name="Text 65"/>
+          <p:cNvSpPr/>
+          <p:nvPr/>
+        </p:nvSpPr>
+        <p:spPr>
+          <a:xfrm>
+            <a:off x="694944" y="2907792"/>
+            <a:ext cx="1133856" cy="201168"/>
+          </a:xfrm>
+          <a:prstGeom prst="rect">
+            <a:avLst/>
+          </a:prstGeom>
+          <a:noFill/>
+          <a:ln/>
+        </p:spPr>
+        <p:txBody>
+          <a:bodyPr wrap="square" lIns="0" tIns="0" rIns="0" bIns="0" rtlCol="0" anchor="ctr"/>
+          <a:lstStyle/>
+          <a:p>
+            <a:pPr marL="0" indent="0">
+              <a:buNone/>
+            </a:pPr>
+            <a:r>
+              <a:rPr lang="en-US" sz="900" b="1" dirty="0">
+                <a:solidFill>
+                  <a:srgbClr val="263238"/>
+                </a:solidFill>
+                <a:latin typeface="Calibri" pitchFamily="34" charset="0"/>
+                <a:ea typeface="Calibri" pitchFamily="34" charset="-122"/>
+                <a:cs typeface="Calibri" pitchFamily="34" charset="-120"/>
+              </a:rPr>
+              <a:t>Authenticate</a:t>
+            </a:r>
+            <a:endParaRPr lang="en-US" sz="900" dirty="0"/>
+          </a:p>
+        </p:txBody>
+      </p:sp>
+      <p:sp>
+        <p:nvSpPr>
+          <p:cNvPr id="68" name="Text 66"/>
+          <p:cNvSpPr/>
+          <p:nvPr/>
+        </p:nvSpPr>
+        <p:spPr>
+          <a:xfrm>
+            <a:off x="694944" y="3108960"/>
+            <a:ext cx="1133856" cy="201168"/>
+          </a:xfrm>
+          <a:prstGeom prst="rect">
+            <a:avLst/>
+          </a:prstGeom>
+          <a:noFill/>
+          <a:ln/>
+        </p:spPr>
+        <p:txBody>
+          <a:bodyPr wrap="square" lIns="0" tIns="0" rIns="0" bIns="0" rtlCol="0" anchor="t"/>
+          <a:lstStyle/>
+          <a:p>
+            <a:pPr marL="0" indent="0">
+              <a:buNone/>
+            </a:pPr>
+            <a:r>
+              <a:rPr lang="en-US" sz="650" dirty="0">
+                <a:solidFill>
+                  <a:srgbClr val="78909C"/>
+                </a:solidFill>
+                <a:latin typeface="Calibri" pitchFamily="34" charset="0"/>
+                <a:ea typeface="Calibri" pitchFamily="34" charset="-122"/>
+                <a:cs typeface="Calibri" pitchFamily="34" charset="-120"/>
+              </a:rPr>
+              <a:t>SSO via IDP;</a:t>
+            </a:r>
+            <a:endParaRPr lang="en-US" sz="650" dirty="0"/>
+          </a:p>
+          <a:p>
+            <a:pPr marL="0" indent="0">
+              <a:buNone/>
+            </a:pPr>
+            <a:r>
+              <a:rPr lang="en-US" sz="650" dirty="0">
+                <a:solidFill>
+                  <a:srgbClr val="78909C"/>
+                </a:solidFill>
+                <a:latin typeface="Calibri" pitchFamily="34" charset="0"/>
+                <a:ea typeface="Calibri" pitchFamily="34" charset="-122"/>
+                <a:cs typeface="Calibri" pitchFamily="34" charset="-120"/>
+              </a:rPr>
+              <a:t>identity propagated to agent</a:t>
+            </a:r>
+            <a:endParaRPr lang="en-US" sz="650" dirty="0"/>
+          </a:p>
+        </p:txBody>
+      </p:sp>
+      <p:sp>
+        <p:nvSpPr>
+          <p:cNvPr id="69" name="Shape 67"/>
+          <p:cNvSpPr/>
+          <p:nvPr/>
+        </p:nvSpPr>
+        <p:spPr>
+          <a:xfrm>
+            <a:off x="2176272" y="2852928"/>
+            <a:ext cx="1243584" cy="512064"/>
+          </a:xfrm>
+          <a:prstGeom prst="rect">
+            <a:avLst/>
+          </a:prstGeom>
+          <a:solidFill>
+            <a:srgbClr val="F5F5F5"/>
+          </a:solidFill>
+          <a:ln w="6350">
+            <a:solidFill>
+              <a:srgbClr val="E8E8E8"/>
+            </a:solidFill>
+            <a:prstDash val="solid"/>
+          </a:ln>
+          <a:effectLst>
+            <a:outerShdw blurRad="38100" dist="12700" dir="8100000" algn="bl" rotWithShape="0">
+              <a:srgbClr val="000000">
+                <a:alpha val="6000"/>
+              </a:srgbClr>
+            </a:outerShdw>
+          </a:effectLst>
+        </p:spPr>
+        <p:txBody>
+          <a:bodyPr/>
+          <a:lstStyle/>
+          <a:p>
+            <a:endParaRPr lang="en-US"/>
+          </a:p>
+        </p:txBody>
+      </p:sp>
+      <p:sp>
+        <p:nvSpPr>
+          <p:cNvPr id="70" name="Shape 68"/>
+          <p:cNvSpPr/>
+          <p:nvPr/>
+        </p:nvSpPr>
+        <p:spPr>
+          <a:xfrm>
+            <a:off x="2176272" y="2852928"/>
+            <a:ext cx="1243584" cy="27432"/>
+          </a:xfrm>
+          <a:prstGeom prst="rect">
+            <a:avLst/>
+          </a:prstGeom>
+          <a:solidFill>
+            <a:srgbClr val="D71E28"/>
+          </a:solidFill>
+          <a:ln/>
+        </p:spPr>
+        <p:txBody>
+          <a:bodyPr/>
+          <a:lstStyle/>
+          <a:p>
+            <a:endParaRPr lang="en-US"/>
+          </a:p>
+        </p:txBody>
+      </p:sp>
+      <p:sp>
+        <p:nvSpPr>
+          <p:cNvPr id="71" name="Text 69"/>
+          <p:cNvSpPr/>
+          <p:nvPr/>
+        </p:nvSpPr>
+        <p:spPr>
+          <a:xfrm>
+            <a:off x="2231136" y="2907792"/>
+            <a:ext cx="1133856" cy="201168"/>
+          </a:xfrm>
+          <a:prstGeom prst="rect">
+            <a:avLst/>
+          </a:prstGeom>
+          <a:noFill/>
+          <a:ln/>
+        </p:spPr>
+        <p:txBody>
+          <a:bodyPr wrap="square" lIns="0" tIns="0" rIns="0" bIns="0" rtlCol="0" anchor="ctr"/>
+          <a:lstStyle/>
+          <a:p>
+            <a:pPr marL="0" indent="0">
+              <a:buNone/>
+            </a:pPr>
+            <a:r>
+              <a:rPr lang="en-US" sz="900" b="1" dirty="0">
+                <a:solidFill>
+                  <a:srgbClr val="263238"/>
+                </a:solidFill>
+                <a:latin typeface="Calibri" pitchFamily="34" charset="0"/>
+                <a:ea typeface="Calibri" pitchFamily="34" charset="-122"/>
+                <a:cs typeface="Calibri" pitchFamily="34" charset="-120"/>
+              </a:rPr>
+              <a:t>Query</a:t>
+            </a:r>
+            <a:endParaRPr lang="en-US" sz="900" dirty="0"/>
+          </a:p>
+        </p:txBody>
+      </p:sp>
+      <p:sp>
+        <p:nvSpPr>
+          <p:cNvPr id="72" name="Text 70"/>
+          <p:cNvSpPr/>
+          <p:nvPr/>
+        </p:nvSpPr>
+        <p:spPr>
+          <a:xfrm>
+            <a:off x="2231136" y="3108960"/>
+            <a:ext cx="1133856" cy="201168"/>
+          </a:xfrm>
+          <a:prstGeom prst="rect">
+            <a:avLst/>
+          </a:prstGeom>
+          <a:noFill/>
+          <a:ln/>
+        </p:spPr>
+        <p:txBody>
+          <a:bodyPr wrap="square" lIns="0" tIns="0" rIns="0" bIns="0" rtlCol="0" anchor="t"/>
+          <a:lstStyle/>
+          <a:p>
+            <a:pPr marL="0" indent="0">
+              <a:buNone/>
+            </a:pPr>
+            <a:r>
+              <a:rPr lang="en-US" sz="650" dirty="0">
+                <a:solidFill>
+                  <a:srgbClr val="78909C"/>
+                </a:solidFill>
+                <a:latin typeface="Calibri" pitchFamily="34" charset="0"/>
+                <a:ea typeface="Calibri" pitchFamily="34" charset="-122"/>
+                <a:cs typeface="Calibri" pitchFamily="34" charset="-120"/>
+              </a:rPr>
+              <a:t>Developer poses question</a:t>
+            </a:r>
+            <a:endParaRPr lang="en-US" sz="650" dirty="0"/>
+          </a:p>
+          <a:p>
+            <a:pPr marL="0" indent="0">
+              <a:buNone/>
+            </a:pPr>
+            <a:r>
+              <a:rPr lang="en-US" sz="650" dirty="0">
+                <a:solidFill>
+                  <a:srgbClr val="78909C"/>
+                </a:solidFill>
+                <a:latin typeface="Calibri" pitchFamily="34" charset="0"/>
+                <a:ea typeface="Calibri" pitchFamily="34" charset="-122"/>
+                <a:cs typeface="Calibri" pitchFamily="34" charset="-120"/>
+              </a:rPr>
+              <a:t>in natural language</a:t>
+            </a:r>
+            <a:endParaRPr lang="en-US" sz="650" dirty="0"/>
+          </a:p>
+        </p:txBody>
+      </p:sp>
+      <p:sp>
+        <p:nvSpPr>
+          <p:cNvPr id="73" name="Shape 71"/>
+          <p:cNvSpPr/>
+          <p:nvPr/>
+        </p:nvSpPr>
+        <p:spPr>
+          <a:xfrm>
+            <a:off x="3712464" y="2852928"/>
+            <a:ext cx="1243584" cy="512064"/>
+          </a:xfrm>
+          <a:prstGeom prst="rect">
+            <a:avLst/>
+          </a:prstGeom>
+          <a:solidFill>
+            <a:srgbClr val="F5F5F5"/>
+          </a:solidFill>
+          <a:ln w="6350">
+            <a:solidFill>
+              <a:srgbClr val="E8E8E8"/>
+            </a:solidFill>
+            <a:prstDash val="solid"/>
+          </a:ln>
+          <a:effectLst>
+            <a:outerShdw blurRad="38100" dist="12700" dir="8100000" algn="bl" rotWithShape="0">
+              <a:srgbClr val="000000">
+                <a:alpha val="6000"/>
+              </a:srgbClr>
+            </a:outerShdw>
+          </a:effectLst>
+        </p:spPr>
+        <p:txBody>
+          <a:bodyPr/>
+          <a:lstStyle/>
+          <a:p>
+            <a:endParaRPr lang="en-US"/>
+          </a:p>
+        </p:txBody>
+      </p:sp>
+      <p:sp>
+        <p:nvSpPr>
+          <p:cNvPr id="74" name="Shape 72"/>
+          <p:cNvSpPr/>
+          <p:nvPr/>
+        </p:nvSpPr>
+        <p:spPr>
+          <a:xfrm>
+            <a:off x="3712464" y="2852928"/>
+            <a:ext cx="1243584" cy="27432"/>
+          </a:xfrm>
+          <a:prstGeom prst="rect">
+            <a:avLst/>
+          </a:prstGeom>
+          <a:solidFill>
+            <a:srgbClr val="D71E28"/>
+          </a:solidFill>
+          <a:ln/>
+        </p:spPr>
+        <p:txBody>
+          <a:bodyPr/>
+          <a:lstStyle/>
+          <a:p>
+            <a:endParaRPr lang="en-US"/>
+          </a:p>
+        </p:txBody>
+      </p:sp>
+      <p:sp>
+        <p:nvSpPr>
+          <p:cNvPr id="75" name="Text 73"/>
+          <p:cNvSpPr/>
+          <p:nvPr/>
+        </p:nvSpPr>
+        <p:spPr>
+          <a:xfrm>
+            <a:off x="3767328" y="2907792"/>
+            <a:ext cx="1133856" cy="201168"/>
+          </a:xfrm>
+          <a:prstGeom prst="rect">
+            <a:avLst/>
+          </a:prstGeom>
+          <a:noFill/>
+          <a:ln/>
+        </p:spPr>
+        <p:txBody>
+          <a:bodyPr wrap="square" lIns="0" tIns="0" rIns="0" bIns="0" rtlCol="0" anchor="ctr"/>
+          <a:lstStyle/>
+          <a:p>
+            <a:pPr marL="0" indent="0">
+              <a:buNone/>
+            </a:pPr>
+            <a:r>
+              <a:rPr lang="en-US" sz="900" b="1" dirty="0">
+                <a:solidFill>
+                  <a:srgbClr val="263238"/>
+                </a:solidFill>
+                <a:latin typeface="Calibri" pitchFamily="34" charset="0"/>
+                <a:ea typeface="Calibri" pitchFamily="34" charset="-122"/>
+                <a:cs typeface="Calibri" pitchFamily="34" charset="-120"/>
+              </a:rPr>
+              <a:t>Orchestrate</a:t>
+            </a:r>
+            <a:endParaRPr lang="en-US" sz="900" dirty="0"/>
+          </a:p>
+        </p:txBody>
+      </p:sp>
+      <p:sp>
+        <p:nvSpPr>
+          <p:cNvPr id="76" name="Text 74"/>
+          <p:cNvSpPr/>
+          <p:nvPr/>
+        </p:nvSpPr>
+        <p:spPr>
+          <a:xfrm>
+            <a:off x="3767328" y="3108960"/>
+            <a:ext cx="1133856" cy="201168"/>
+          </a:xfrm>
+          <a:prstGeom prst="rect">
+            <a:avLst/>
+          </a:prstGeom>
+          <a:noFill/>
+          <a:ln/>
+        </p:spPr>
+        <p:txBody>
+          <a:bodyPr wrap="square" lIns="0" tIns="0" rIns="0" bIns="0" rtlCol="0" anchor="t"/>
+          <a:lstStyle/>
+          <a:p>
+            <a:pPr marL="0" indent="0">
+              <a:buNone/>
+            </a:pPr>
+            <a:r>
+              <a:rPr lang="en-US" sz="650" dirty="0">
+                <a:solidFill>
+                  <a:srgbClr val="78909C"/>
+                </a:solidFill>
+                <a:latin typeface="Calibri" pitchFamily="34" charset="0"/>
+                <a:ea typeface="Calibri" pitchFamily="34" charset="-122"/>
+                <a:cs typeface="Calibri" pitchFamily="34" charset="-120"/>
+              </a:rPr>
+              <a:t>Supervisor routes to</a:t>
+            </a:r>
+            <a:endParaRPr lang="en-US" sz="650" dirty="0"/>
+          </a:p>
+          <a:p>
+            <a:pPr marL="0" indent="0">
+              <a:buNone/>
+            </a:pPr>
+            <a:r>
+              <a:rPr lang="en-US" sz="650" dirty="0">
+                <a:solidFill>
+                  <a:srgbClr val="78909C"/>
+                </a:solidFill>
+                <a:latin typeface="Calibri" pitchFamily="34" charset="0"/>
+                <a:ea typeface="Calibri" pitchFamily="34" charset="-122"/>
+                <a:cs typeface="Calibri" pitchFamily="34" charset="-120"/>
+              </a:rPr>
+              <a:t>specialized sub-agent</a:t>
+            </a:r>
+            <a:endParaRPr lang="en-US" sz="650" dirty="0"/>
+          </a:p>
+        </p:txBody>
+      </p:sp>
+      <p:sp>
+        <p:nvSpPr>
+          <p:cNvPr id="77" name="Shape 75"/>
+          <p:cNvSpPr/>
+          <p:nvPr/>
+        </p:nvSpPr>
+        <p:spPr>
+          <a:xfrm>
+            <a:off x="5248656" y="2852928"/>
+            <a:ext cx="1243584" cy="512064"/>
+          </a:xfrm>
+          <a:prstGeom prst="rect">
+            <a:avLst/>
+          </a:prstGeom>
+          <a:solidFill>
+            <a:srgbClr val="F5F5F5"/>
+          </a:solidFill>
+          <a:ln w="6350">
+            <a:solidFill>
+              <a:srgbClr val="E8E8E8"/>
+            </a:solidFill>
+            <a:prstDash val="solid"/>
+          </a:ln>
+          <a:effectLst>
+            <a:outerShdw blurRad="38100" dist="12700" dir="8100000" algn="bl" rotWithShape="0">
+              <a:srgbClr val="000000">
+                <a:alpha val="6000"/>
+              </a:srgbClr>
+            </a:outerShdw>
+          </a:effectLst>
+        </p:spPr>
+        <p:txBody>
+          <a:bodyPr/>
+          <a:lstStyle/>
+          <a:p>
+            <a:endParaRPr lang="en-US"/>
+          </a:p>
+        </p:txBody>
+      </p:sp>
+      <p:sp>
+        <p:nvSpPr>
+          <p:cNvPr id="78" name="Shape 76"/>
+          <p:cNvSpPr/>
+          <p:nvPr/>
+        </p:nvSpPr>
+        <p:spPr>
+          <a:xfrm>
+            <a:off x="5248656" y="2852928"/>
+            <a:ext cx="1243584" cy="27432"/>
+          </a:xfrm>
+          <a:prstGeom prst="rect">
+            <a:avLst/>
+          </a:prstGeom>
+          <a:solidFill>
+            <a:srgbClr val="D71E28"/>
+          </a:solidFill>
+          <a:ln/>
+        </p:spPr>
+        <p:txBody>
+          <a:bodyPr/>
+          <a:lstStyle/>
+          <a:p>
+            <a:endParaRPr lang="en-US"/>
+          </a:p>
+        </p:txBody>
+      </p:sp>
+      <p:sp>
+        <p:nvSpPr>
+          <p:cNvPr id="79" name="Text 77"/>
+          <p:cNvSpPr/>
+          <p:nvPr/>
+        </p:nvSpPr>
+        <p:spPr>
+          <a:xfrm>
+            <a:off x="5303520" y="2907792"/>
+            <a:ext cx="1133856" cy="201168"/>
+          </a:xfrm>
+          <a:prstGeom prst="rect">
+            <a:avLst/>
+          </a:prstGeom>
+          <a:noFill/>
+          <a:ln/>
+        </p:spPr>
+        <p:txBody>
+          <a:bodyPr wrap="square" lIns="0" tIns="0" rIns="0" bIns="0" rtlCol="0" anchor="ctr"/>
+          <a:lstStyle/>
+          <a:p>
+            <a:pPr marL="0" indent="0">
+              <a:buNone/>
+            </a:pPr>
+            <a:r>
+              <a:rPr lang="en-US" sz="900" b="1" dirty="0">
+                <a:solidFill>
+                  <a:srgbClr val="263238"/>
+                </a:solidFill>
+                <a:latin typeface="Calibri" pitchFamily="34" charset="0"/>
+                <a:ea typeface="Calibri" pitchFamily="34" charset="-122"/>
+                <a:cs typeface="Calibri" pitchFamily="34" charset="-120"/>
+              </a:rPr>
+              <a:t>Retrieve</a:t>
+            </a:r>
+            <a:endParaRPr lang="en-US" sz="900" dirty="0"/>
+          </a:p>
+        </p:txBody>
+      </p:sp>
+      <p:sp>
+        <p:nvSpPr>
+          <p:cNvPr id="80" name="Text 78"/>
+          <p:cNvSpPr/>
+          <p:nvPr/>
+        </p:nvSpPr>
+        <p:spPr>
+          <a:xfrm>
+            <a:off x="5303520" y="3108960"/>
+            <a:ext cx="1133856" cy="201168"/>
+          </a:xfrm>
+          <a:prstGeom prst="rect">
+            <a:avLst/>
+          </a:prstGeom>
+          <a:noFill/>
+          <a:ln/>
+        </p:spPr>
+        <p:txBody>
+          <a:bodyPr wrap="square" lIns="0" tIns="0" rIns="0" bIns="0" rtlCol="0" anchor="t"/>
+          <a:lstStyle/>
+          <a:p>
+            <a:pPr marL="0" indent="0">
+              <a:buNone/>
+            </a:pPr>
+            <a:r>
+              <a:rPr lang="en-US" sz="650" dirty="0">
+                <a:solidFill>
+                  <a:srgbClr val="78909C"/>
+                </a:solidFill>
+                <a:latin typeface="Calibri" pitchFamily="34" charset="0"/>
+                <a:ea typeface="Calibri" pitchFamily="34" charset="-122"/>
+                <a:cs typeface="Calibri" pitchFamily="34" charset="-120"/>
+              </a:rPr>
+              <a:t>Agent queries MCPs,</a:t>
+            </a:r>
+            <a:endParaRPr lang="en-US" sz="650" dirty="0"/>
+          </a:p>
+          <a:p>
+            <a:pPr marL="0" indent="0">
+              <a:buNone/>
+            </a:pPr>
+            <a:r>
+              <a:rPr lang="en-US" sz="650" dirty="0">
+                <a:solidFill>
+                  <a:srgbClr val="78909C"/>
+                </a:solidFill>
+                <a:latin typeface="Calibri" pitchFamily="34" charset="0"/>
+                <a:ea typeface="Calibri" pitchFamily="34" charset="-122"/>
+                <a:cs typeface="Calibri" pitchFamily="34" charset="-120"/>
+              </a:rPr>
+              <a:t>APIs &amp; knowledge base</a:t>
+            </a:r>
+            <a:endParaRPr lang="en-US" sz="650" dirty="0"/>
+          </a:p>
+        </p:txBody>
+      </p:sp>
+      <p:sp>
+        <p:nvSpPr>
+          <p:cNvPr id="81" name="Shape 79"/>
+          <p:cNvSpPr/>
+          <p:nvPr/>
+        </p:nvSpPr>
+        <p:spPr>
+          <a:xfrm>
+            <a:off x="6784848" y="2852928"/>
+            <a:ext cx="1243584" cy="512064"/>
+          </a:xfrm>
+          <a:prstGeom prst="rect">
+            <a:avLst/>
+          </a:prstGeom>
+          <a:solidFill>
+            <a:srgbClr val="F5F5F5"/>
+          </a:solidFill>
+          <a:ln w="6350">
+            <a:solidFill>
+              <a:srgbClr val="E8E8E8"/>
+            </a:solidFill>
+            <a:prstDash val="solid"/>
+          </a:ln>
+          <a:effectLst>
+            <a:outerShdw blurRad="38100" dist="12700" dir="8100000" algn="bl" rotWithShape="0">
+              <a:srgbClr val="000000">
+                <a:alpha val="6000"/>
+              </a:srgbClr>
+            </a:outerShdw>
+          </a:effectLst>
+        </p:spPr>
+        <p:txBody>
+          <a:bodyPr/>
+          <a:lstStyle/>
+          <a:p>
+            <a:endParaRPr lang="en-US"/>
+          </a:p>
+        </p:txBody>
+      </p:sp>
+      <p:sp>
+        <p:nvSpPr>
+          <p:cNvPr id="82" name="Shape 80"/>
+          <p:cNvSpPr/>
+          <p:nvPr/>
+        </p:nvSpPr>
+        <p:spPr>
+          <a:xfrm>
+            <a:off x="6784848" y="2852928"/>
+            <a:ext cx="1243584" cy="27432"/>
+          </a:xfrm>
+          <a:prstGeom prst="rect">
+            <a:avLst/>
+          </a:prstGeom>
+          <a:solidFill>
+            <a:srgbClr val="D71E28"/>
+          </a:solidFill>
+          <a:ln/>
+        </p:spPr>
+        <p:txBody>
+          <a:bodyPr/>
+          <a:lstStyle/>
+          <a:p>
+            <a:endParaRPr lang="en-US"/>
+          </a:p>
+        </p:txBody>
+      </p:sp>
+      <p:sp>
+        <p:nvSpPr>
+          <p:cNvPr id="83" name="Text 81"/>
+          <p:cNvSpPr/>
+          <p:nvPr/>
+        </p:nvSpPr>
+        <p:spPr>
+          <a:xfrm>
+            <a:off x="6839712" y="2907792"/>
+            <a:ext cx="1133856" cy="201168"/>
+          </a:xfrm>
+          <a:prstGeom prst="rect">
+            <a:avLst/>
+          </a:prstGeom>
+          <a:noFill/>
+          <a:ln/>
+        </p:spPr>
+        <p:txBody>
+          <a:bodyPr wrap="square" lIns="0" tIns="0" rIns="0" bIns="0" rtlCol="0" anchor="ctr"/>
+          <a:lstStyle/>
+          <a:p>
+            <a:pPr marL="0" indent="0">
+              <a:buNone/>
+            </a:pPr>
+            <a:r>
+              <a:rPr lang="en-US" sz="900" b="1" dirty="0">
+                <a:solidFill>
+                  <a:srgbClr val="263238"/>
+                </a:solidFill>
+                <a:latin typeface="Calibri" pitchFamily="34" charset="0"/>
+                <a:ea typeface="Calibri" pitchFamily="34" charset="-122"/>
+                <a:cs typeface="Calibri" pitchFamily="34" charset="-120"/>
+              </a:rPr>
+              <a:t>Respond</a:t>
+            </a:r>
+            <a:endParaRPr lang="en-US" sz="900" dirty="0"/>
+          </a:p>
+        </p:txBody>
+      </p:sp>
+      <p:sp>
+        <p:nvSpPr>
+          <p:cNvPr id="84" name="Text 82"/>
+          <p:cNvSpPr/>
+          <p:nvPr/>
+        </p:nvSpPr>
+        <p:spPr>
+          <a:xfrm>
+            <a:off x="6839712" y="3108960"/>
+            <a:ext cx="1133856" cy="201168"/>
+          </a:xfrm>
+          <a:prstGeom prst="rect">
+            <a:avLst/>
+          </a:prstGeom>
+          <a:noFill/>
+          <a:ln/>
+        </p:spPr>
+        <p:txBody>
+          <a:bodyPr wrap="square" lIns="0" tIns="0" rIns="0" bIns="0" rtlCol="0" anchor="t"/>
+          <a:lstStyle/>
+          <a:p>
+            <a:pPr marL="0" indent="0">
+              <a:buNone/>
+            </a:pPr>
+            <a:r>
+              <a:rPr lang="en-US" sz="650" dirty="0">
+                <a:solidFill>
+                  <a:srgbClr val="78909C"/>
+                </a:solidFill>
+                <a:latin typeface="Calibri" pitchFamily="34" charset="0"/>
+                <a:ea typeface="Calibri" pitchFamily="34" charset="-122"/>
+                <a:cs typeface="Calibri" pitchFamily="34" charset="-120"/>
+              </a:rPr>
+              <a:t>Consolidated answer</a:t>
+            </a:r>
+            <a:endParaRPr lang="en-US" sz="650" dirty="0"/>
+          </a:p>
+          <a:p>
+            <a:pPr marL="0" indent="0">
+              <a:buNone/>
+            </a:pPr>
+            <a:r>
+              <a:rPr lang="en-US" sz="650" dirty="0">
+                <a:solidFill>
+                  <a:srgbClr val="78909C"/>
+                </a:solidFill>
+                <a:latin typeface="Calibri" pitchFamily="34" charset="0"/>
+                <a:ea typeface="Calibri" pitchFamily="34" charset="-122"/>
+                <a:cs typeface="Calibri" pitchFamily="34" charset="-120"/>
+              </a:rPr>
+              <a:t>with source citations</a:t>
+            </a:r>
+            <a:endParaRPr lang="en-US" sz="650" dirty="0"/>
+          </a:p>
+        </p:txBody>
+      </p:sp>
+      <p:sp>
+        <p:nvSpPr>
+          <p:cNvPr id="85" name="Shape 83"/>
+          <p:cNvSpPr/>
+          <p:nvPr/>
+        </p:nvSpPr>
+        <p:spPr>
+          <a:xfrm>
+            <a:off x="1920240" y="3108960"/>
+            <a:ext cx="219456" cy="0"/>
+          </a:xfrm>
+          <a:prstGeom prst="line">
+            <a:avLst/>
+          </a:prstGeom>
+          <a:noFill/>
+          <a:ln w="12700">
+            <a:solidFill>
+              <a:srgbClr val="D71E28"/>
+            </a:solidFill>
+            <a:prstDash val="solid"/>
+            <a:tailEnd type="triangle"/>
+          </a:ln>
+        </p:spPr>
+        <p:txBody>
+          <a:bodyPr/>
+          <a:lstStyle/>
+          <a:p>
+            <a:endParaRPr lang="en-US"/>
+          </a:p>
+        </p:txBody>
+      </p:sp>
+      <p:sp>
+        <p:nvSpPr>
+          <p:cNvPr id="86" name="Shape 84"/>
+          <p:cNvSpPr/>
+          <p:nvPr/>
+        </p:nvSpPr>
+        <p:spPr>
+          <a:xfrm>
+            <a:off x="3456432" y="3108960"/>
+            <a:ext cx="219456" cy="0"/>
+          </a:xfrm>
+          <a:prstGeom prst="line">
+            <a:avLst/>
+          </a:prstGeom>
+          <a:noFill/>
+          <a:ln w="12700">
+            <a:solidFill>
+              <a:srgbClr val="D71E28"/>
+            </a:solidFill>
+            <a:prstDash val="solid"/>
+            <a:tailEnd type="triangle"/>
+          </a:ln>
+        </p:spPr>
+        <p:txBody>
+          <a:bodyPr/>
+          <a:lstStyle/>
+          <a:p>
+            <a:endParaRPr lang="en-US"/>
+          </a:p>
+        </p:txBody>
+      </p:sp>
+      <p:sp>
+        <p:nvSpPr>
+          <p:cNvPr id="87" name="Shape 85"/>
+          <p:cNvSpPr/>
+          <p:nvPr/>
+        </p:nvSpPr>
+        <p:spPr>
+          <a:xfrm>
+            <a:off x="4992624" y="3108960"/>
+            <a:ext cx="219456" cy="0"/>
+          </a:xfrm>
+          <a:prstGeom prst="line">
+            <a:avLst/>
+          </a:prstGeom>
+          <a:noFill/>
+          <a:ln w="12700">
+            <a:solidFill>
+              <a:srgbClr val="D71E28"/>
+            </a:solidFill>
+            <a:prstDash val="solid"/>
+            <a:tailEnd type="triangle"/>
+          </a:ln>
+        </p:spPr>
+        <p:txBody>
+          <a:bodyPr/>
+          <a:lstStyle/>
+          <a:p>
+            <a:endParaRPr lang="en-US"/>
+          </a:p>
+        </p:txBody>
+      </p:sp>
+      <p:sp>
+        <p:nvSpPr>
+          <p:cNvPr id="88" name="Shape 86"/>
+          <p:cNvSpPr/>
+          <p:nvPr/>
+        </p:nvSpPr>
+        <p:spPr>
+          <a:xfrm>
+            <a:off x="6528816" y="3108960"/>
+            <a:ext cx="219456" cy="0"/>
+          </a:xfrm>
+          <a:prstGeom prst="line">
+            <a:avLst/>
+          </a:prstGeom>
+          <a:noFill/>
+          <a:ln w="12700">
+            <a:solidFill>
+              <a:srgbClr val="D71E28"/>
+            </a:solidFill>
+            <a:prstDash val="solid"/>
+            <a:tailEnd type="triangle"/>
+          </a:ln>
+        </p:spPr>
+        <p:txBody>
+          <a:bodyPr/>
+          <a:lstStyle/>
+          <a:p>
+            <a:endParaRPr lang="en-US"/>
+          </a:p>
+        </p:txBody>
+      </p:sp>
+      <p:sp>
+        <p:nvSpPr>
+          <p:cNvPr id="89" name="Shape 87"/>
+          <p:cNvSpPr/>
+          <p:nvPr/>
+        </p:nvSpPr>
+        <p:spPr>
+          <a:xfrm>
+            <a:off x="7406640" y="3364992"/>
+            <a:ext cx="0" cy="128016"/>
+          </a:xfrm>
+          <a:prstGeom prst="line">
+            <a:avLst/>
+          </a:prstGeom>
+          <a:noFill/>
+          <a:ln w="10160">
+            <a:solidFill>
+              <a:srgbClr val="BDBDBD"/>
+            </a:solidFill>
+            <a:prstDash val="dash"/>
+          </a:ln>
+        </p:spPr>
+        <p:txBody>
+          <a:bodyPr/>
+          <a:lstStyle/>
+          <a:p>
+            <a:endParaRPr lang="en-US"/>
+          </a:p>
+        </p:txBody>
+      </p:sp>
+      <p:sp>
+        <p:nvSpPr>
+          <p:cNvPr id="90" name="Shape 88"/>
+          <p:cNvSpPr/>
+          <p:nvPr/>
+        </p:nvSpPr>
+        <p:spPr>
+          <a:xfrm>
+            <a:off x="2798064" y="3493008"/>
+            <a:ext cx="4608576" cy="0"/>
+          </a:xfrm>
+          <a:prstGeom prst="line">
+            <a:avLst/>
+          </a:prstGeom>
+          <a:noFill/>
+          <a:ln w="10160">
+            <a:solidFill>
+              <a:srgbClr val="BDBDBD"/>
+            </a:solidFill>
+            <a:prstDash val="dash"/>
+          </a:ln>
+        </p:spPr>
+        <p:txBody>
+          <a:bodyPr/>
+          <a:lstStyle/>
+          <a:p>
+            <a:endParaRPr lang="en-US"/>
+          </a:p>
+        </p:txBody>
+      </p:sp>
+      <p:sp>
+        <p:nvSpPr>
+          <p:cNvPr id="91" name="Shape 89"/>
+          <p:cNvSpPr/>
+          <p:nvPr/>
+        </p:nvSpPr>
+        <p:spPr>
+          <a:xfrm>
+            <a:off x="2798064" y="3493008"/>
+            <a:ext cx="0" cy="0"/>
+          </a:xfrm>
+          <a:prstGeom prst="line">
+            <a:avLst/>
+          </a:prstGeom>
+          <a:noFill/>
+          <a:ln w="10160">
+            <a:solidFill>
+              <a:srgbClr val="BDBDBD"/>
+            </a:solidFill>
+            <a:prstDash val="dash"/>
+            <a:tailEnd type="triangle"/>
+          </a:ln>
+        </p:spPr>
+        <p:txBody>
+          <a:bodyPr/>
+          <a:lstStyle/>
+          <a:p>
+            <a:endParaRPr lang="en-US"/>
+          </a:p>
+        </p:txBody>
+      </p:sp>
+      <p:sp>
+        <p:nvSpPr>
+          <p:cNvPr id="92" name="Text 90"/>
+          <p:cNvSpPr/>
+          <p:nvPr/>
+        </p:nvSpPr>
+        <p:spPr>
+          <a:xfrm>
+            <a:off x="4736592" y="3502152"/>
+            <a:ext cx="731520" cy="128016"/>
+          </a:xfrm>
+          <a:prstGeom prst="rect">
+            <a:avLst/>
+          </a:prstGeom>
+          <a:noFill/>
+          <a:ln/>
+        </p:spPr>
+        <p:txBody>
+          <a:bodyPr wrap="square" lIns="0" tIns="0" rIns="0" bIns="0" rtlCol="0" anchor="ctr"/>
+          <a:lstStyle/>
+          <a:p>
+            <a:pPr marL="0" indent="0" algn="ctr">
+              <a:buNone/>
+            </a:pPr>
+            <a:r>
+              <a:rPr lang="en-US" sz="600" i="1" dirty="0">
+                <a:solidFill>
+                  <a:srgbClr val="78909C"/>
+                </a:solidFill>
+                <a:latin typeface="Calibri" pitchFamily="34" charset="0"/>
+                <a:ea typeface="Calibri" pitchFamily="34" charset="-122"/>
+                <a:cs typeface="Calibri" pitchFamily="34" charset="-120"/>
+              </a:rPr>
+              <a:t>Follow-up</a:t>
+            </a:r>
+            <a:endParaRPr lang="en-US" sz="600" dirty="0"/>
+          </a:p>
+        </p:txBody>
+      </p:sp>
+      <p:sp>
+        <p:nvSpPr>
+          <p:cNvPr id="93" name="Shape 91"/>
           <p:cNvSpPr/>
           <p:nvPr/>
         </p:nvSpPr>

</xml_diff>